<commit_message>
Replace vision deck slide 2: verified stats only, no vendor content
Slide 2 previously paired a "where we stand today" problem list with
vendor-sponsored AI-cost stats (Harness/Sapio). Flagged as less relevant.

Replaced entirely with a "why now" slide built on State of FinOps 2026 alone
— 78% of practices now report into the CTO/CIO org, 98% manage AI spend as a
core cost, and governance now ranks above optimization in 2026 priorities.
Same evidence that worked well in the CIO brief, with no vendor sponsor
anywhere on the slide. The three original "no owner / late data / nothing
stops a runaway" gaps are still argued on slide 1 (the vision statement) and
implicitly through slides 3-4, so nothing is lost by dropping the list.

Co-Authored-By: Claude Opus 5 <noreply@anthropic.com>
Claude-Session: https://claude.ai/code/session_01WYWPNu6P9u6t1ivaNyJxST
</commit_message>
<xml_diff>
--- a/presentations/finops-vision.pptx
+++ b/presentations/finops-vision.pptx
@@ -594,7 +594,7 @@
           <a:p>
             <a:r>
               <a:rPr lang="en-US" dirty="0"/>
-              <a:t>The diagnosis, in three gaps, and none of them is a reporting gap — dashboards exist today. The gap is that a number moving does not yet mean anyone can say why. Replace the three external stats with our own position before presenting: how long the last unexplained increase actually took to explain, what share of spend is currently unallocated, and whether any workload has a hard ceiling today. Our own numbers are worth more here than any industry figure. The card on the right is context, not the argument — say unprompted that the AI figures are from vendor-sponsored research, and that the 78% figure is the one to trust unconditionally: FinOps has become a technology-organization function industry-wide, which is why this is being presented here rather than to finance alone.</a:t>
+              <a:t>This slide answers 'why is this on the agenda now', with external evidence rather than our own complaint. The 78% figure matters most: FinOps has moved from a finance reporting function to a technology capability, and it now sits in the CTO/CIO organization in most practices — up eighteen points in three years. That is the industry telling us where accountability belongs. The middle card is the scope point. Practices are no longer managing cloud alone — AI spend is now near-universal, SaaS is close behind, data centre is climbing. Build allocation and ownership for all of it, or rebuild the same work twice. The third card pre-empts the obvious pushback, 'haven't we already done the cost work?'. Optimization dropped below governance in the 2026 priorities because mature practices hit diminishing returns on hunting waste after the fact — the returns now come from ownership and governance, which is exactly what slides 3 and 4 propose. Attribute the numbers to the State of FinOps 2026 out loud. This is external evidence, not our opinion, and it is the strongest slide in the deck for that reason.</a:t>
             </a:r>
             <a:endParaRPr lang="en-US" dirty="0"/>
           </a:p>
@@ -2066,7 +2066,7 @@
                 <a:ea typeface="Calibri" pitchFamily="34" charset="-122"/>
                 <a:cs typeface="Calibri" pitchFamily="34" charset="-120"/>
               </a:rPr>
-              <a:t>WHERE WE ARE TODAY</a:t>
+              <a:t>WHY NOW</a:t>
             </a:r>
             <a:endParaRPr lang="en-US" sz="1100" dirty="0"/>
           </a:p>
@@ -2105,7 +2105,7 @@
                 <a:ea typeface="Cambria" pitchFamily="34" charset="-122"/>
                 <a:cs typeface="Cambria" pitchFamily="34" charset="-120"/>
               </a:rPr>
-              <a:t>The bill arrives before the explanation</a:t>
+              <a:t>This is where the industry is already going</a:t>
             </a:r>
             <a:endParaRPr lang="en-US" sz="3100" dirty="0"/>
           </a:p>
@@ -2144,7 +2144,7 @@
                 <a:ea typeface="Calibri" pitchFamily="34" charset="-122"/>
                 <a:cs typeface="Calibri" pitchFamily="34" charset="-120"/>
               </a:rPr>
-              <a:t>Three gaps, and none of them is a reporting problem — reports we have.</a:t>
+              <a:t>FinOps Foundation, State of FinOps 2026 (n ≈ 1,500 practitioners worldwide).</a:t>
             </a:r>
             <a:endParaRPr lang="en-US" sz="1500" dirty="0"/>
           </a:p>
@@ -2158,74 +2158,30 @@
         </p:nvSpPr>
         <p:spPr>
           <a:xfrm>
-            <a:off x="548640" y="2103120"/>
-            <a:ext cx="6675120" cy="1133856"/>
+            <a:off x="548640" y="2121408"/>
+            <a:ext cx="3511296" cy="2743200"/>
           </a:xfrm>
           <a:prstGeom prst="roundRect">
             <a:avLst>
-              <a:gd name="adj" fmla="val 7258"/>
+              <a:gd name="adj" fmla="val 3000"/>
             </a:avLst>
           </a:prstGeom>
           <a:solidFill>
-            <a:srgbClr val="F1F3F6"/>
+            <a:srgbClr val="1F2936"/>
           </a:solidFill>
           <a:ln/>
         </p:spPr>
       </p:sp>
       <p:sp>
         <p:nvSpPr>
-          <p:cNvPr id="6" name="Shape 4"/>
-          <p:cNvSpPr/>
-          <p:nvPr/>
-        </p:nvSpPr>
-        <p:spPr>
-          <a:xfrm>
-            <a:off x="859536" y="2432304"/>
-            <a:ext cx="475488" cy="475488"/>
-          </a:xfrm>
-          <a:prstGeom prst="ellipse">
-            <a:avLst/>
-          </a:prstGeom>
-          <a:solidFill>
-            <a:srgbClr val="FFFFFF"/>
-          </a:solidFill>
-          <a:ln/>
-        </p:spPr>
-      </p:sp>
-      <p:pic>
-        <p:nvPicPr>
-          <p:cNvPr id="7" name="Image 0" descr="preencoded.png">    </p:cNvPr>
-          <p:cNvPicPr>
-            <a:picLocks noChangeAspect="1"/>
-          </p:cNvPicPr>
-          <p:nvPr/>
-        </p:nvPicPr>
-        <p:blipFill>
-          <a:blip r:embed="rId1"/>
-          <a:stretch>
-            <a:fillRect/>
-          </a:stretch>
-        </p:blipFill>
-        <p:spPr>
-          <a:xfrm>
-            <a:off x="978408" y="2551176"/>
-            <a:ext cx="237744" cy="237744"/>
-          </a:xfrm>
-          <a:prstGeom prst="rect">
-            <a:avLst/>
-          </a:prstGeom>
-        </p:spPr>
-      </p:pic>
-      <p:sp>
-        <p:nvSpPr>
-          <p:cNvPr id="8" name="Text 5"/>
-          <p:cNvSpPr/>
-          <p:nvPr/>
-        </p:nvSpPr>
-        <p:spPr>
-          <a:xfrm>
-            <a:off x="1517904" y="2103120"/>
-            <a:ext cx="5486400" cy="1133856"/>
+          <p:cNvPr id="6" name="Text 4"/>
+          <p:cNvSpPr/>
+          <p:nvPr/>
+        </p:nvSpPr>
+        <p:spPr>
+          <a:xfrm>
+            <a:off x="859536" y="2377440"/>
+            <a:ext cx="2926080" cy="914400"/>
           </a:xfrm>
           <a:prstGeom prst="rect">
             <a:avLst/>
@@ -2238,122 +2194,139 @@
           <a:lstStyle/>
           <a:p>
             <a:pPr indent="0" marL="0">
+              <a:buNone/>
+            </a:pPr>
+            <a:r>
+              <a:rPr lang="en-US" sz="4600" b="1" dirty="0">
+                <a:solidFill>
+                  <a:srgbClr val="E39B2C"/>
+                </a:solidFill>
+                <a:latin typeface="Cambria" pitchFamily="34" charset="0"/>
+                <a:ea typeface="Cambria" pitchFamily="34" charset="-122"/>
+                <a:cs typeface="Cambria" pitchFamily="34" charset="-120"/>
+              </a:rPr>
+              <a:t>78%</a:t>
+            </a:r>
+            <a:endParaRPr lang="en-US" sz="4600" dirty="0"/>
+          </a:p>
+        </p:txBody>
+      </p:sp>
+      <p:sp>
+        <p:nvSpPr>
+          <p:cNvPr id="7" name="Text 5"/>
+          <p:cNvSpPr/>
+          <p:nvPr/>
+        </p:nvSpPr>
+        <p:spPr>
+          <a:xfrm>
+            <a:off x="859536" y="3364992"/>
+            <a:ext cx="2926080" cy="914400"/>
+          </a:xfrm>
+          <a:prstGeom prst="rect">
+            <a:avLst/>
+          </a:prstGeom>
+          <a:noFill/>
+          <a:ln/>
+        </p:spPr>
+        <p:txBody>
+          <a:bodyPr wrap="square" lIns="0" tIns="0" rIns="0" bIns="0" rtlCol="0" anchor="t"/>
+          <a:lstStyle/>
+          <a:p>
+            <a:pPr indent="0" marL="0">
               <a:lnSpc>
-                <a:spcPts val="1700"/>
+                <a:spcPts val="1900"/>
               </a:lnSpc>
               <a:buNone/>
             </a:pPr>
             <a:r>
-              <a:rPr lang="en-US" sz="1450" b="1" dirty="0">
-                <a:solidFill>
-                  <a:srgbClr val="1B2430"/>
-                </a:solidFill>
-                <a:latin typeface="Calibri" pitchFamily="34" charset="0"/>
-                <a:ea typeface="Calibri" pitchFamily="34" charset="-122"/>
-                <a:cs typeface="Calibri" pitchFamily="34" charset="-120"/>
-              </a:rPr>
-              <a:t>No owner on the change</a:t>
-            </a:r>
-            <a:endParaRPr lang="en-US" sz="1450" dirty="0"/>
-          </a:p>
+              <a:rPr lang="en-US" sz="1400" dirty="0">
+                <a:solidFill>
+                  <a:srgbClr val="FFFFFF"/>
+                </a:solidFill>
+                <a:latin typeface="Calibri" pitchFamily="34" charset="0"/>
+                <a:ea typeface="Calibri" pitchFamily="34" charset="-122"/>
+                <a:cs typeface="Calibri" pitchFamily="34" charset="-120"/>
+              </a:rPr>
+              <a:t>of FinOps practices now report into the CTO/CIO organization</a:t>
+            </a:r>
+            <a:endParaRPr lang="en-US" sz="1400" dirty="0"/>
+          </a:p>
+        </p:txBody>
+      </p:sp>
+      <p:sp>
+        <p:nvSpPr>
+          <p:cNvPr id="8" name="Text 6"/>
+          <p:cNvSpPr/>
+          <p:nvPr/>
+        </p:nvSpPr>
+        <p:spPr>
+          <a:xfrm>
+            <a:off x="859536" y="4297680"/>
+            <a:ext cx="2926080" cy="457200"/>
+          </a:xfrm>
+          <a:prstGeom prst="rect">
+            <a:avLst/>
+          </a:prstGeom>
+          <a:noFill/>
+          <a:ln/>
+        </p:spPr>
+        <p:txBody>
+          <a:bodyPr wrap="square" lIns="0" tIns="0" rIns="0" bIns="0" rtlCol="0" anchor="t"/>
+          <a:lstStyle/>
           <a:p>
             <a:pPr indent="0" marL="0">
               <a:lnSpc>
-                <a:spcPts val="1700"/>
+                <a:spcPts val="1500"/>
               </a:lnSpc>
               <a:buNone/>
             </a:pPr>
             <a:r>
-              <a:rPr lang="en-US" sz="1250" dirty="0">
-                <a:solidFill>
-                  <a:srgbClr val="5C6675"/>
-                </a:solidFill>
-                <a:latin typeface="Calibri" pitchFamily="34" charset="0"/>
-                <a:ea typeface="Calibri" pitchFamily="34" charset="-122"/>
-                <a:cs typeface="Calibri" pitchFamily="34" charset="-120"/>
-              </a:rPr>
-              <a:t>When the number moves, naming who caused it takes days. Often it is never established at all.</a:t>
-            </a:r>
-            <a:endParaRPr lang="en-US" sz="1450" dirty="0"/>
-          </a:p>
-        </p:txBody>
-      </p:sp>
-      <p:sp>
-        <p:nvSpPr>
-          <p:cNvPr id="9" name="Shape 6"/>
-          <p:cNvSpPr/>
-          <p:nvPr/>
-        </p:nvSpPr>
-        <p:spPr>
-          <a:xfrm>
-            <a:off x="548640" y="3328416"/>
-            <a:ext cx="6675120" cy="1133856"/>
+              <a:rPr lang="en-US" sz="1150" dirty="0">
+                <a:solidFill>
+                  <a:srgbClr val="9EABBA"/>
+                </a:solidFill>
+                <a:latin typeface="Calibri" pitchFamily="34" charset="0"/>
+                <a:ea typeface="Calibri" pitchFamily="34" charset="-122"/>
+                <a:cs typeface="Calibri" pitchFamily="34" charset="-120"/>
+              </a:rPr>
+              <a:t>up 18 points since 2023</a:t>
+            </a:r>
+            <a:endParaRPr lang="en-US" sz="1150" dirty="0"/>
+          </a:p>
+        </p:txBody>
+      </p:sp>
+      <p:sp>
+        <p:nvSpPr>
+          <p:cNvPr id="9" name="Shape 7"/>
+          <p:cNvSpPr/>
+          <p:nvPr/>
+        </p:nvSpPr>
+        <p:spPr>
+          <a:xfrm>
+            <a:off x="4334256" y="2121408"/>
+            <a:ext cx="3511296" cy="2743200"/>
           </a:xfrm>
           <a:prstGeom prst="roundRect">
             <a:avLst>
-              <a:gd name="adj" fmla="val 7258"/>
+              <a:gd name="adj" fmla="val 3000"/>
             </a:avLst>
           </a:prstGeom>
           <a:solidFill>
-            <a:srgbClr val="F1F3F6"/>
+            <a:srgbClr val="DDEDE9"/>
           </a:solidFill>
           <a:ln/>
         </p:spPr>
       </p:sp>
       <p:sp>
         <p:nvSpPr>
-          <p:cNvPr id="10" name="Shape 7"/>
-          <p:cNvSpPr/>
-          <p:nvPr/>
-        </p:nvSpPr>
-        <p:spPr>
-          <a:xfrm>
-            <a:off x="859536" y="3657600"/>
-            <a:ext cx="475488" cy="475488"/>
-          </a:xfrm>
-          <a:prstGeom prst="ellipse">
-            <a:avLst/>
-          </a:prstGeom>
-          <a:solidFill>
-            <a:srgbClr val="FFFFFF"/>
-          </a:solidFill>
-          <a:ln/>
-        </p:spPr>
-      </p:sp>
-      <p:pic>
-        <p:nvPicPr>
-          <p:cNvPr id="11" name="Image 1" descr="preencoded.png">    </p:cNvPr>
-          <p:cNvPicPr>
-            <a:picLocks noChangeAspect="1"/>
-          </p:cNvPicPr>
-          <p:nvPr/>
-        </p:nvPicPr>
-        <p:blipFill>
-          <a:blip r:embed="rId2"/>
-          <a:stretch>
-            <a:fillRect/>
-          </a:stretch>
-        </p:blipFill>
-        <p:spPr>
-          <a:xfrm>
-            <a:off x="978408" y="3776472"/>
-            <a:ext cx="237744" cy="237744"/>
-          </a:xfrm>
-          <a:prstGeom prst="rect">
-            <a:avLst/>
-          </a:prstGeom>
-        </p:spPr>
-      </p:pic>
-      <p:sp>
-        <p:nvSpPr>
-          <p:cNvPr id="12" name="Text 8"/>
-          <p:cNvSpPr/>
-          <p:nvPr/>
-        </p:nvSpPr>
-        <p:spPr>
-          <a:xfrm>
-            <a:off x="1517904" y="3328416"/>
-            <a:ext cx="5486400" cy="1133856"/>
+          <p:cNvPr id="10" name="Text 8"/>
+          <p:cNvSpPr/>
+          <p:nvPr/>
+        </p:nvSpPr>
+        <p:spPr>
+          <a:xfrm>
+            <a:off x="4645152" y="2377440"/>
+            <a:ext cx="2926080" cy="914400"/>
           </a:xfrm>
           <a:prstGeom prst="rect">
             <a:avLst/>
@@ -2366,13 +2339,52 @@
           <a:lstStyle/>
           <a:p>
             <a:pPr indent="0" marL="0">
+              <a:buNone/>
+            </a:pPr>
+            <a:r>
+              <a:rPr lang="en-US" sz="4600" b="1" dirty="0">
+                <a:solidFill>
+                  <a:srgbClr val="1F6B5C"/>
+                </a:solidFill>
+                <a:latin typeface="Cambria" pitchFamily="34" charset="0"/>
+                <a:ea typeface="Cambria" pitchFamily="34" charset="-122"/>
+                <a:cs typeface="Cambria" pitchFamily="34" charset="-120"/>
+              </a:rPr>
+              <a:t>98%</a:t>
+            </a:r>
+            <a:endParaRPr lang="en-US" sz="4600" dirty="0"/>
+          </a:p>
+        </p:txBody>
+      </p:sp>
+      <p:sp>
+        <p:nvSpPr>
+          <p:cNvPr id="11" name="Text 9"/>
+          <p:cNvSpPr/>
+          <p:nvPr/>
+        </p:nvSpPr>
+        <p:spPr>
+          <a:xfrm>
+            <a:off x="4645152" y="3364992"/>
+            <a:ext cx="2926080" cy="914400"/>
+          </a:xfrm>
+          <a:prstGeom prst="rect">
+            <a:avLst/>
+          </a:prstGeom>
+          <a:noFill/>
+          <a:ln/>
+        </p:spPr>
+        <p:txBody>
+          <a:bodyPr wrap="square" lIns="0" tIns="0" rIns="0" bIns="0" rtlCol="0" anchor="t"/>
+          <a:lstStyle/>
+          <a:p>
+            <a:pPr indent="0" marL="0">
               <a:lnSpc>
-                <a:spcPts val="1700"/>
+                <a:spcPts val="1900"/>
               </a:lnSpc>
               <a:buNone/>
             </a:pPr>
             <a:r>
-              <a:rPr lang="en-US" sz="1450" b="1" dirty="0">
+              <a:rPr lang="en-US" sz="1400" dirty="0">
                 <a:solidFill>
                   <a:srgbClr val="1B2430"/>
                 </a:solidFill>
@@ -2380,19 +2392,41 @@
                 <a:ea typeface="Calibri" pitchFamily="34" charset="-122"/>
                 <a:cs typeface="Calibri" pitchFamily="34" charset="-120"/>
               </a:rPr>
-              <a:t>The data arrives too late</a:t>
-            </a:r>
-            <a:endParaRPr lang="en-US" sz="1450" dirty="0"/>
-          </a:p>
+              <a:t>of practices now manage AI spend as a core operating cost</a:t>
+            </a:r>
+            <a:endParaRPr lang="en-US" sz="1400" dirty="0"/>
+          </a:p>
+        </p:txBody>
+      </p:sp>
+      <p:sp>
+        <p:nvSpPr>
+          <p:cNvPr id="12" name="Text 10"/>
+          <p:cNvSpPr/>
+          <p:nvPr/>
+        </p:nvSpPr>
+        <p:spPr>
+          <a:xfrm>
+            <a:off x="4645152" y="4297680"/>
+            <a:ext cx="2926080" cy="457200"/>
+          </a:xfrm>
+          <a:prstGeom prst="rect">
+            <a:avLst/>
+          </a:prstGeom>
+          <a:noFill/>
+          <a:ln/>
+        </p:spPr>
+        <p:txBody>
+          <a:bodyPr wrap="square" lIns="0" tIns="0" rIns="0" bIns="0" rtlCol="0" anchor="t"/>
+          <a:lstStyle/>
           <a:p>
             <a:pPr indent="0" marL="0">
               <a:lnSpc>
-                <a:spcPts val="1700"/>
+                <a:spcPts val="1500"/>
               </a:lnSpc>
               <a:buNone/>
             </a:pPr>
             <a:r>
-              <a:rPr lang="en-US" sz="1250" dirty="0">
+              <a:rPr lang="en-US" sz="1150" dirty="0">
                 <a:solidFill>
                   <a:srgbClr val="5C6675"/>
                 </a:solidFill>
@@ -2400,88 +2434,44 @@
                 <a:ea typeface="Calibri" pitchFamily="34" charset="-122"/>
                 <a:cs typeface="Calibri" pitchFamily="34" charset="-120"/>
               </a:rPr>
-              <a:t>Billing lands a day or two behind, so every cost alert reports what already happened.</a:t>
-            </a:r>
-            <a:endParaRPr lang="en-US" sz="1450" dirty="0"/>
-          </a:p>
-        </p:txBody>
-      </p:sp>
-      <p:sp>
-        <p:nvSpPr>
-          <p:cNvPr id="13" name="Shape 9"/>
-          <p:cNvSpPr/>
-          <p:nvPr/>
-        </p:nvSpPr>
-        <p:spPr>
-          <a:xfrm>
-            <a:off x="548640" y="4553712"/>
-            <a:ext cx="6675120" cy="1133856"/>
+              <a:t>SaaS 90% · licensing 64% · data centre 48%</a:t>
+            </a:r>
+            <a:endParaRPr lang="en-US" sz="1150" dirty="0"/>
+          </a:p>
+        </p:txBody>
+      </p:sp>
+      <p:sp>
+        <p:nvSpPr>
+          <p:cNvPr id="13" name="Shape 11"/>
+          <p:cNvSpPr/>
+          <p:nvPr/>
+        </p:nvSpPr>
+        <p:spPr>
+          <a:xfrm>
+            <a:off x="8119872" y="2121408"/>
+            <a:ext cx="3511296" cy="2743200"/>
           </a:xfrm>
           <a:prstGeom prst="roundRect">
             <a:avLst>
-              <a:gd name="adj" fmla="val 7258"/>
+              <a:gd name="adj" fmla="val 3000"/>
             </a:avLst>
           </a:prstGeom>
           <a:solidFill>
-            <a:srgbClr val="F1F3F6"/>
+            <a:srgbClr val="FBEFD8"/>
           </a:solidFill>
           <a:ln/>
         </p:spPr>
       </p:sp>
       <p:sp>
         <p:nvSpPr>
-          <p:cNvPr id="14" name="Shape 10"/>
-          <p:cNvSpPr/>
-          <p:nvPr/>
-        </p:nvSpPr>
-        <p:spPr>
-          <a:xfrm>
-            <a:off x="859536" y="4882896"/>
-            <a:ext cx="475488" cy="475488"/>
-          </a:xfrm>
-          <a:prstGeom prst="ellipse">
-            <a:avLst/>
-          </a:prstGeom>
-          <a:solidFill>
-            <a:srgbClr val="FFFFFF"/>
-          </a:solidFill>
-          <a:ln/>
-        </p:spPr>
-      </p:sp>
-      <p:pic>
-        <p:nvPicPr>
-          <p:cNvPr id="15" name="Image 2" descr="preencoded.png">    </p:cNvPr>
-          <p:cNvPicPr>
-            <a:picLocks noChangeAspect="1"/>
-          </p:cNvPicPr>
-          <p:nvPr/>
-        </p:nvPicPr>
-        <p:blipFill>
-          <a:blip r:embed="rId3"/>
-          <a:stretch>
-            <a:fillRect/>
-          </a:stretch>
-        </p:blipFill>
-        <p:spPr>
-          <a:xfrm>
-            <a:off x="978408" y="5001768"/>
-            <a:ext cx="237744" cy="237744"/>
-          </a:xfrm>
-          <a:prstGeom prst="rect">
-            <a:avLst/>
-          </a:prstGeom>
-        </p:spPr>
-      </p:pic>
-      <p:sp>
-        <p:nvSpPr>
-          <p:cNvPr id="16" name="Text 11"/>
-          <p:cNvSpPr/>
-          <p:nvPr/>
-        </p:nvSpPr>
-        <p:spPr>
-          <a:xfrm>
-            <a:off x="1517904" y="4553712"/>
-            <a:ext cx="5486400" cy="1133856"/>
+          <p:cNvPr id="14" name="Text 12"/>
+          <p:cNvSpPr/>
+          <p:nvPr/>
+        </p:nvSpPr>
+        <p:spPr>
+          <a:xfrm>
+            <a:off x="8430768" y="2377440"/>
+            <a:ext cx="2926080" cy="914400"/>
           </a:xfrm>
           <a:prstGeom prst="rect">
             <a:avLst/>
@@ -2494,13 +2484,52 @@
           <a:lstStyle/>
           <a:p>
             <a:pPr indent="0" marL="0">
+              <a:buNone/>
+            </a:pPr>
+            <a:r>
+              <a:rPr lang="en-US" sz="4600" b="1" dirty="0">
+                <a:solidFill>
+                  <a:srgbClr val="B87B18"/>
+                </a:solidFill>
+                <a:latin typeface="Cambria" pitchFamily="34" charset="0"/>
+                <a:ea typeface="Cambria" pitchFamily="34" charset="-122"/>
+                <a:cs typeface="Cambria" pitchFamily="34" charset="-120"/>
+              </a:rPr>
+              <a:t>#3</a:t>
+            </a:r>
+            <a:endParaRPr lang="en-US" sz="4600" dirty="0"/>
+          </a:p>
+        </p:txBody>
+      </p:sp>
+      <p:sp>
+        <p:nvSpPr>
+          <p:cNvPr id="15" name="Text 13"/>
+          <p:cNvSpPr/>
+          <p:nvPr/>
+        </p:nvSpPr>
+        <p:spPr>
+          <a:xfrm>
+            <a:off x="8430768" y="3364992"/>
+            <a:ext cx="2926080" cy="914400"/>
+          </a:xfrm>
+          <a:prstGeom prst="rect">
+            <a:avLst/>
+          </a:prstGeom>
+          <a:noFill/>
+          <a:ln/>
+        </p:spPr>
+        <p:txBody>
+          <a:bodyPr wrap="square" lIns="0" tIns="0" rIns="0" bIns="0" rtlCol="0" anchor="t"/>
+          <a:lstStyle/>
+          <a:p>
+            <a:pPr indent="0" marL="0">
               <a:lnSpc>
-                <a:spcPts val="1700"/>
+                <a:spcPts val="1900"/>
               </a:lnSpc>
               <a:buNone/>
             </a:pPr>
             <a:r>
-              <a:rPr lang="en-US" sz="1450" b="1" dirty="0">
+              <a:rPr lang="en-US" sz="1400" dirty="0">
                 <a:solidFill>
                   <a:srgbClr val="1B2430"/>
                 </a:solidFill>
@@ -2508,19 +2537,41 @@
                 <a:ea typeface="Calibri" pitchFamily="34" charset="-122"/>
                 <a:cs typeface="Calibri" pitchFamily="34" charset="-120"/>
               </a:rPr>
-              <a:t>Nothing stops a runaway</a:t>
-            </a:r>
-            <a:endParaRPr lang="en-US" sz="1450" dirty="0"/>
-          </a:p>
+              <a:t>governance ranks above optimization in 2026 priorities</a:t>
+            </a:r>
+            <a:endParaRPr lang="en-US" sz="1400" dirty="0"/>
+          </a:p>
+        </p:txBody>
+      </p:sp>
+      <p:sp>
+        <p:nvSpPr>
+          <p:cNvPr id="16" name="Text 14"/>
+          <p:cNvSpPr/>
+          <p:nvPr/>
+        </p:nvSpPr>
+        <p:spPr>
+          <a:xfrm>
+            <a:off x="8430768" y="4297680"/>
+            <a:ext cx="2926080" cy="457200"/>
+          </a:xfrm>
+          <a:prstGeom prst="rect">
+            <a:avLst/>
+          </a:prstGeom>
+          <a:noFill/>
+          <a:ln/>
+        </p:spPr>
+        <p:txBody>
+          <a:bodyPr wrap="square" lIns="0" tIns="0" rIns="0" bIns="0" rtlCol="0" anchor="t"/>
+          <a:lstStyle/>
           <a:p>
             <a:pPr indent="0" marL="0">
               <a:lnSpc>
-                <a:spcPts val="1700"/>
+                <a:spcPts val="1500"/>
               </a:lnSpc>
               <a:buNone/>
             </a:pPr>
             <a:r>
-              <a:rPr lang="en-US" sz="1250" dirty="0">
+              <a:rPr lang="en-US" sz="1150" dirty="0">
                 <a:solidFill>
                   <a:srgbClr val="5C6675"/>
                 </a:solidFill>
@@ -2528,26 +2579,26 @@
                 <a:ea typeface="Calibri" pitchFamily="34" charset="-122"/>
                 <a:cs typeface="Calibri" pitchFamily="34" charset="-120"/>
               </a:rPr>
-              <a:t>No quota, no ceiling, no approval gate. The first hard limit is the invoice.</a:t>
-            </a:r>
-            <a:endParaRPr lang="en-US" sz="1450" dirty="0"/>
-          </a:p>
-        </p:txBody>
-      </p:sp>
-      <p:sp>
-        <p:nvSpPr>
-          <p:cNvPr id="17" name="Shape 12"/>
-          <p:cNvSpPr/>
-          <p:nvPr/>
-        </p:nvSpPr>
-        <p:spPr>
-          <a:xfrm>
-            <a:off x="7525512" y="2103120"/>
-            <a:ext cx="4114800" cy="3694176"/>
+              <a:t>behind only AI cost management and AI-driven efficiency</a:t>
+            </a:r>
+            <a:endParaRPr lang="en-US" sz="1150" dirty="0"/>
+          </a:p>
+        </p:txBody>
+      </p:sp>
+      <p:sp>
+        <p:nvSpPr>
+          <p:cNvPr id="17" name="Shape 15"/>
+          <p:cNvSpPr/>
+          <p:nvPr/>
+        </p:nvSpPr>
+        <p:spPr>
+          <a:xfrm>
+            <a:off x="548640" y="5084064"/>
+            <a:ext cx="11091672" cy="1536192"/>
           </a:xfrm>
           <a:prstGeom prst="roundRect">
             <a:avLst>
-              <a:gd name="adj" fmla="val 2228"/>
+              <a:gd name="adj" fmla="val 5357"/>
             </a:avLst>
           </a:prstGeom>
           <a:solidFill>
@@ -2565,14 +2616,14 @@
       </p:sp>
       <p:sp>
         <p:nvSpPr>
-          <p:cNvPr id="18" name="Text 13"/>
-          <p:cNvSpPr/>
-          <p:nvPr/>
-        </p:nvSpPr>
-        <p:spPr>
-          <a:xfrm>
-            <a:off x="7836408" y="2286000"/>
-            <a:ext cx="3657600" cy="292608"/>
+          <p:cNvPr id="18" name="Text 16"/>
+          <p:cNvSpPr/>
+          <p:nvPr/>
+        </p:nvSpPr>
+        <p:spPr>
+          <a:xfrm>
+            <a:off x="877824" y="5248656"/>
+            <a:ext cx="7315200" cy="292608"/>
           </a:xfrm>
           <a:prstGeom prst="rect">
             <a:avLst/>
@@ -2596,7 +2647,7 @@
                 <a:ea typeface="Calibri" pitchFamily="34" charset="-122"/>
                 <a:cs typeface="Calibri" pitchFamily="34" charset="-120"/>
               </a:rPr>
-              <a:t>We are not alone in this</a:t>
+              <a:t>What it means for this organization</a:t>
             </a:r>
             <a:endParaRPr lang="en-US" sz="1150" dirty="0"/>
           </a:p>
@@ -2604,72 +2655,50 @@
       </p:sp>
       <p:sp>
         <p:nvSpPr>
-          <p:cNvPr id="19" name="Text 14"/>
-          <p:cNvSpPr/>
-          <p:nvPr/>
-        </p:nvSpPr>
-        <p:spPr>
-          <a:xfrm>
-            <a:off x="7836408" y="2651760"/>
-            <a:ext cx="3566160" cy="402336"/>
-          </a:xfrm>
-          <a:prstGeom prst="rect">
-            <a:avLst/>
-          </a:prstGeom>
-          <a:noFill/>
-          <a:ln/>
-        </p:spPr>
-        <p:txBody>
-          <a:bodyPr wrap="square" lIns="0" tIns="0" rIns="0" bIns="0" rtlCol="0" anchor="ctr"/>
-          <a:lstStyle/>
-          <a:p>
-            <a:pPr indent="0" marL="0">
-              <a:buNone/>
-            </a:pPr>
-            <a:r>
-              <a:rPr lang="en-US" sz="2400" b="1" dirty="0">
+          <p:cNvPr id="19" name="Text 17"/>
+          <p:cNvSpPr/>
+          <p:nvPr/>
+        </p:nvSpPr>
+        <p:spPr>
+          <a:xfrm>
+            <a:off x="877824" y="5577840"/>
+            <a:ext cx="10424160" cy="960120"/>
+          </a:xfrm>
+          <a:prstGeom prst="rect">
+            <a:avLst/>
+          </a:prstGeom>
+          <a:noFill/>
+          <a:ln/>
+        </p:spPr>
+        <p:txBody>
+          <a:bodyPr wrap="square" lIns="0" tIns="0" rIns="0" bIns="0" rtlCol="0" anchor="t"/>
+          <a:lstStyle/>
+          <a:p>
+            <a:pPr indent="0" marL="0">
+              <a:lnSpc>
+                <a:spcPts val="2000"/>
+              </a:lnSpc>
+              <a:buNone/>
+            </a:pPr>
+            <a:r>
+              <a:rPr lang="en-US" sz="1350" b="1" dirty="0">
                 <a:solidFill>
                   <a:srgbClr val="FFFFFF"/>
                 </a:solidFill>
-                <a:latin typeface="Cambria" pitchFamily="34" charset="0"/>
-                <a:ea typeface="Cambria" pitchFamily="34" charset="-122"/>
-                <a:cs typeface="Cambria" pitchFamily="34" charset="-120"/>
-              </a:rPr>
-              <a:t>4 in 5</a:t>
-            </a:r>
-            <a:endParaRPr lang="en-US" sz="2400" dirty="0"/>
-          </a:p>
-        </p:txBody>
-      </p:sp>
-      <p:sp>
-        <p:nvSpPr>
-          <p:cNvPr id="20" name="Text 15"/>
-          <p:cNvSpPr/>
-          <p:nvPr/>
-        </p:nvSpPr>
-        <p:spPr>
-          <a:xfrm>
-            <a:off x="7836408" y="3054096"/>
-            <a:ext cx="3529584" cy="457200"/>
-          </a:xfrm>
-          <a:prstGeom prst="rect">
-            <a:avLst/>
-          </a:prstGeom>
-          <a:noFill/>
-          <a:ln/>
-        </p:spPr>
-        <p:txBody>
-          <a:bodyPr wrap="square" lIns="0" tIns="0" rIns="0" bIns="0" rtlCol="0" anchor="t"/>
-          <a:lstStyle/>
-          <a:p>
+                <a:latin typeface="Calibri" pitchFamily="34" charset="0"/>
+                <a:ea typeface="Calibri" pitchFamily="34" charset="-122"/>
+                <a:cs typeface="Calibri" pitchFamily="34" charset="-120"/>
+              </a:rPr>
+              <a:t>Cost control has stopped being a finance report and become a technology capability — </a:t>
+            </a:r>
             <a:pPr indent="0" marL="0">
               <a:lnSpc>
-                <a:spcPts val="1500"/>
+                <a:spcPts val="2000"/>
               </a:lnSpc>
               <a:buNone/>
             </a:pPr>
             <a:r>
-              <a:rPr lang="en-US" sz="1150" dirty="0">
+              <a:rPr lang="en-US" sz="1350" dirty="0">
                 <a:solidFill>
                   <a:srgbClr val="9EABBA"/>
                 </a:solidFill>
@@ -2677,285 +2706,9 @@
                 <a:ea typeface="Calibri" pitchFamily="34" charset="-122"/>
                 <a:cs typeface="Calibri" pitchFamily="34" charset="-120"/>
               </a:rPr>
-              <a:t>need a day or more to trace an AI cost spike to its source</a:t>
-            </a:r>
-            <a:endParaRPr lang="en-US" sz="1150" dirty="0"/>
-          </a:p>
-        </p:txBody>
-      </p:sp>
-      <p:sp>
-        <p:nvSpPr>
-          <p:cNvPr id="21" name="Text 16"/>
-          <p:cNvSpPr/>
-          <p:nvPr/>
-        </p:nvSpPr>
-        <p:spPr>
-          <a:xfrm>
-            <a:off x="7836408" y="3584448"/>
-            <a:ext cx="3566160" cy="402336"/>
-          </a:xfrm>
-          <a:prstGeom prst="rect">
-            <a:avLst/>
-          </a:prstGeom>
-          <a:noFill/>
-          <a:ln/>
-        </p:spPr>
-        <p:txBody>
-          <a:bodyPr wrap="square" lIns="0" tIns="0" rIns="0" bIns="0" rtlCol="0" anchor="ctr"/>
-          <a:lstStyle/>
-          <a:p>
-            <a:pPr indent="0" marL="0">
-              <a:buNone/>
-            </a:pPr>
-            <a:r>
-              <a:rPr lang="en-US" sz="2400" b="1" dirty="0">
-                <a:solidFill>
-                  <a:srgbClr val="FFFFFF"/>
-                </a:solidFill>
-                <a:latin typeface="Cambria" pitchFamily="34" charset="0"/>
-                <a:ea typeface="Cambria" pitchFamily="34" charset="-122"/>
-                <a:cs typeface="Cambria" pitchFamily="34" charset="-120"/>
-              </a:rPr>
-              <a:t>52%</a:t>
-            </a:r>
-            <a:endParaRPr lang="en-US" sz="2400" dirty="0"/>
-          </a:p>
-        </p:txBody>
-      </p:sp>
-      <p:sp>
-        <p:nvSpPr>
-          <p:cNvPr id="22" name="Text 17"/>
-          <p:cNvSpPr/>
-          <p:nvPr/>
-        </p:nvSpPr>
-        <p:spPr>
-          <a:xfrm>
-            <a:off x="7836408" y="3986784"/>
-            <a:ext cx="3529584" cy="457200"/>
-          </a:xfrm>
-          <a:prstGeom prst="rect">
-            <a:avLst/>
-          </a:prstGeom>
-          <a:noFill/>
-          <a:ln/>
-        </p:spPr>
-        <p:txBody>
-          <a:bodyPr wrap="square" lIns="0" tIns="0" rIns="0" bIns="0" rtlCol="0" anchor="t"/>
-          <a:lstStyle/>
-          <a:p>
-            <a:pPr indent="0" marL="0">
-              <a:lnSpc>
-                <a:spcPts val="1500"/>
-              </a:lnSpc>
-              <a:buNone/>
-            </a:pPr>
-            <a:r>
-              <a:rPr lang="en-US" sz="1150" dirty="0">
-                <a:solidFill>
-                  <a:srgbClr val="9EABBA"/>
-                </a:solidFill>
-                <a:latin typeface="Calibri" pitchFamily="34" charset="0"/>
-                <a:ea typeface="Calibri" pitchFamily="34" charset="-122"/>
-                <a:cs typeface="Calibri" pitchFamily="34" charset="-120"/>
-              </a:rPr>
-              <a:t>have no clear owner for AI cost at all</a:t>
-            </a:r>
-            <a:endParaRPr lang="en-US" sz="1150" dirty="0"/>
-          </a:p>
-        </p:txBody>
-      </p:sp>
-      <p:sp>
-        <p:nvSpPr>
-          <p:cNvPr id="23" name="Text 18"/>
-          <p:cNvSpPr/>
-          <p:nvPr/>
-        </p:nvSpPr>
-        <p:spPr>
-          <a:xfrm>
-            <a:off x="7836408" y="4517136"/>
-            <a:ext cx="3566160" cy="402336"/>
-          </a:xfrm>
-          <a:prstGeom prst="rect">
-            <a:avLst/>
-          </a:prstGeom>
-          <a:noFill/>
-          <a:ln/>
-        </p:spPr>
-        <p:txBody>
-          <a:bodyPr wrap="square" lIns="0" tIns="0" rIns="0" bIns="0" rtlCol="0" anchor="ctr"/>
-          <a:lstStyle/>
-          <a:p>
-            <a:pPr indent="0" marL="0">
-              <a:buNone/>
-            </a:pPr>
-            <a:r>
-              <a:rPr lang="en-US" sz="2400" b="1" dirty="0">
-                <a:solidFill>
-                  <a:srgbClr val="FFFFFF"/>
-                </a:solidFill>
-                <a:latin typeface="Cambria" pitchFamily="34" charset="0"/>
-                <a:ea typeface="Cambria" pitchFamily="34" charset="-122"/>
-                <a:cs typeface="Cambria" pitchFamily="34" charset="-120"/>
-              </a:rPr>
-              <a:t>78%</a:t>
-            </a:r>
-            <a:endParaRPr lang="en-US" sz="2400" dirty="0"/>
-          </a:p>
-        </p:txBody>
-      </p:sp>
-      <p:sp>
-        <p:nvSpPr>
-          <p:cNvPr id="24" name="Text 19"/>
-          <p:cNvSpPr/>
-          <p:nvPr/>
-        </p:nvSpPr>
-        <p:spPr>
-          <a:xfrm>
-            <a:off x="7836408" y="4919472"/>
-            <a:ext cx="3529584" cy="457200"/>
-          </a:xfrm>
-          <a:prstGeom prst="rect">
-            <a:avLst/>
-          </a:prstGeom>
-          <a:noFill/>
-          <a:ln/>
-        </p:spPr>
-        <p:txBody>
-          <a:bodyPr wrap="square" lIns="0" tIns="0" rIns="0" bIns="0" rtlCol="0" anchor="t"/>
-          <a:lstStyle/>
-          <a:p>
-            <a:pPr indent="0" marL="0">
-              <a:lnSpc>
-                <a:spcPts val="1500"/>
-              </a:lnSpc>
-              <a:buNone/>
-            </a:pPr>
-            <a:r>
-              <a:rPr lang="en-US" sz="1150" dirty="0">
-                <a:solidFill>
-                  <a:srgbClr val="9EABBA"/>
-                </a:solidFill>
-                <a:latin typeface="Calibri" pitchFamily="34" charset="0"/>
-                <a:ea typeface="Calibri" pitchFamily="34" charset="-122"/>
-                <a:cs typeface="Calibri" pitchFamily="34" charset="-120"/>
-              </a:rPr>
-              <a:t>of FinOps practices now sit in the CTO/CIO organization</a:t>
-            </a:r>
-            <a:endParaRPr lang="en-US" sz="1150" dirty="0"/>
-          </a:p>
-        </p:txBody>
-      </p:sp>
-      <p:sp>
-        <p:nvSpPr>
-          <p:cNvPr id="25" name="Text 20"/>
-          <p:cNvSpPr/>
-          <p:nvPr/>
-        </p:nvSpPr>
-        <p:spPr>
-          <a:xfrm>
-            <a:off x="7836408" y="5468112"/>
-            <a:ext cx="3529584" cy="292608"/>
-          </a:xfrm>
-          <a:prstGeom prst="rect">
-            <a:avLst/>
-          </a:prstGeom>
-          <a:noFill/>
-          <a:ln/>
-        </p:spPr>
-        <p:txBody>
-          <a:bodyPr wrap="square" lIns="0" tIns="0" rIns="0" bIns="0" rtlCol="0" anchor="ctr"/>
-          <a:lstStyle/>
-          <a:p>
-            <a:pPr indent="0" marL="0">
-              <a:buNone/>
-            </a:pPr>
-            <a:r>
-              <a:rPr lang="en-US" sz="950" dirty="0">
-                <a:solidFill>
-                  <a:srgbClr val="6E7A88"/>
-                </a:solidFill>
-                <a:latin typeface="Calibri" pitchFamily="34" charset="0"/>
-                <a:ea typeface="Calibri" pitchFamily="34" charset="-122"/>
-                <a:cs typeface="Calibri" pitchFamily="34" charset="-120"/>
-              </a:rPr>
-              <a:t>State of FinOps 2026; Harness / Sapio 2026 (vendor-sponsored).</a:t>
-            </a:r>
-            <a:endParaRPr lang="en-US" sz="950" dirty="0"/>
-          </a:p>
-        </p:txBody>
-      </p:sp>
-      <p:sp>
-        <p:nvSpPr>
-          <p:cNvPr id="26" name="Shape 21"/>
-          <p:cNvSpPr/>
-          <p:nvPr/>
-        </p:nvSpPr>
-        <p:spPr>
-          <a:xfrm>
-            <a:off x="548640" y="5943600"/>
-            <a:ext cx="11091672" cy="676656"/>
-          </a:xfrm>
-          <a:prstGeom prst="roundRect">
-            <a:avLst>
-              <a:gd name="adj" fmla="val 12162"/>
-            </a:avLst>
-          </a:prstGeom>
-          <a:solidFill>
-            <a:srgbClr val="FBEFD8"/>
-          </a:solidFill>
-          <a:ln/>
-        </p:spPr>
-      </p:sp>
-      <p:sp>
-        <p:nvSpPr>
-          <p:cNvPr id="27" name="Text 22"/>
-          <p:cNvSpPr/>
-          <p:nvPr/>
-        </p:nvSpPr>
-        <p:spPr>
-          <a:xfrm>
-            <a:off x="877824" y="5943600"/>
-            <a:ext cx="10424160" cy="676656"/>
-          </a:xfrm>
-          <a:prstGeom prst="rect">
-            <a:avLst/>
-          </a:prstGeom>
-          <a:noFill/>
-          <a:ln/>
-        </p:spPr>
-        <p:txBody>
-          <a:bodyPr wrap="square" lIns="0" tIns="0" rIns="0" bIns="0" rtlCol="0" anchor="ctr"/>
-          <a:lstStyle/>
-          <a:p>
-            <a:pPr indent="0" marL="0">
-              <a:buNone/>
-            </a:pPr>
-            <a:r>
-              <a:rPr lang="en-US" sz="1300" b="1" dirty="0">
-                <a:solidFill>
-                  <a:srgbClr val="6B4A0E"/>
-                </a:solidFill>
-                <a:latin typeface="Calibri" pitchFamily="34" charset="0"/>
-                <a:ea typeface="Calibri" pitchFamily="34" charset="-122"/>
-                <a:cs typeface="Calibri" pitchFamily="34" charset="-120"/>
-              </a:rPr>
-              <a:t>The consequence:  </a:t>
-            </a:r>
-            <a:pPr indent="0" marL="0">
-              <a:buNone/>
-            </a:pPr>
-            <a:r>
-              <a:rPr lang="en-US" sz="1300" dirty="0">
-                <a:solidFill>
-                  <a:srgbClr val="6B4A0E"/>
-                </a:solidFill>
-                <a:latin typeface="Calibri" pitchFamily="34" charset="0"/>
-                <a:ea typeface="Calibri" pitchFamily="34" charset="-122"/>
-                <a:cs typeface="Calibri" pitchFamily="34" charset="-120"/>
-              </a:rPr>
-              <a:t>unexplained variance gets padded into next year's budget, so poor visibility quietly inflates the plan as well as the bill.</a:t>
-            </a:r>
-            <a:endParaRPr lang="en-US" sz="1300" dirty="0"/>
+              <a:t>which puts it on this desk. The industry's own conclusion is that attacking waste after the fact has hit diminishing returns; the returns now come from ownership, governance and scope.</a:t>
+            </a:r>
+            <a:endParaRPr lang="en-US" sz="1350" dirty="0"/>
           </a:p>
         </p:txBody>
       </p:sp>

</xml_diff>

<commit_message>
Remove slide 2 from the vision deck: 5 slides down to 4
Dropped the "why now" slide (State of FinOps 2026 stats) outright rather than
merging it elsewhere. The remaining four stand on their own: the vision
statement, see it (allocation + whole-project pricing), control it (shift left
+ guardrails), and the ask. Renumbered the internal slide-number references in
the vision speaker note accordingly.

Co-Authored-By: Claude Opus 5 <noreply@anthropic.com>
Claude-Session: https://claude.ai/code/session_01WYWPNu6P9u6t1ivaNyJxST
</commit_message>
<xml_diff>
--- a/presentations/finops-vision.pptx
+++ b/presentations/finops-vision.pptx
@@ -9,10 +9,9 @@
     <p:sldId id="257" r:id="rId3"/>
     <p:sldId id="258" r:id="rId4"/>
     <p:sldId id="259" r:id="rId5"/>
-    <p:sldId id="260" r:id="rId6"/>
   </p:sldIdLst>
   <p:notesMasterIdLst>
-    <p:notesMasterId r:id="rId7"/>
+    <p:notesMasterId r:id="rId6"/>
   </p:notesMasterIdLst>
   <p:sldSz cx="12192000" cy="6858000"/>
   <p:notesSz cx="6858000" cy="12192000"/>
@@ -506,7 +505,7 @@
           <a:p>
             <a:r>
               <a:rPr lang="en-US" dirty="0"/>
-              <a:t>Open with the sentence on the slide and stop — let it land before explaining it. Every project has a name, an owner, a number and a limit is the whole vision; everything after this slide is how we get there. Say plainly that this is not a cost-cutting pitch. Cloud and AI are the one large spending line where commitments are made daily, by engineers, with no approval step in between — everywhere else in the budget that would be called a control gap, and closing it is the ask. The four words at the bottom are the structure for the rest of the deck: named and owned are slide 3, measured is slides 3 and 5, limited is slide 4. Naming them here means nothing later needs re-introducing.</a:t>
+              <a:t>Open with the sentence on the slide and stop — let it land before explaining it. Every project has a name, an owner, a number and a limit is the whole vision; everything after this slide is how we get there. Say plainly that this is not a cost-cutting pitch. Cloud and AI are the one large spending line where commitments are made daily, by engineers, with no approval step in between — everywhere else in the budget that would be called a control gap, and closing it is the ask. The four words at the bottom are the structure for the rest of the deck: named and owned are slide 2, measured is slides 2 and 4, limited is slide 3. Naming them here means nothing later needs re-introducing.</a:t>
             </a:r>
             <a:endParaRPr lang="en-US" dirty="0"/>
           </a:p>
@@ -594,7 +593,7 @@
           <a:p>
             <a:r>
               <a:rPr lang="en-US" dirty="0"/>
-              <a:t>This slide answers 'why is this on the agenda now', with external evidence rather than our own complaint. The 78% figure matters most: FinOps has moved from a finance reporting function to a technology capability, and it now sits in the CTO/CIO organization in most practices — up eighteen points in three years. That is the industry telling us where accountability belongs. The middle card is the scope point. Practices are no longer managing cloud alone — AI spend is now near-universal, SaaS is close behind, data centre is climbing. Build allocation and ownership for all of it, or rebuild the same work twice. The third card pre-empts the obvious pushback, 'haven't we already done the cost work?'. Optimization dropped below governance in the 2026 priorities because mature practices hit diminishing returns on hunting waste after the fact — the returns now come from ownership and governance, which is exactly what slides 3 and 4 propose. Attribute the numbers to the State of FinOps 2026 out loud. This is external evidence, not our opinion, and it is the strongest slide in the deck for that reason.</a:t>
+              <a:t>This is the whole of visibility in one slide, deliberately: trace it, and price it whole. The left side is the allocation chain — tag, allocate, showback, divide by a unit — and the single number to commit to is under 5% unallocated, reported weekly. That is the target that makes everything else on this slide possible. The right side is the point most cost conversations miss, and it is worth slowing down for: an AI feature gets quoted at its token cost, but it runs on compute, databases, cache, storage, gateway and log ingestion that bill every month regardless of how heavily the model is called. A project priced at its model line alone will be wrong by the size of everything under it, and the surprise arrives at the first full month, not the pilot. The instruction is the bottom bar: one ApplicationID across every resource a project touches. That is a tagging decision, not an engineering project, and it is the single most impactful thing this room can approve today.</a:t>
             </a:r>
             <a:endParaRPr lang="en-US" dirty="0"/>
           </a:p>
@@ -682,7 +681,7 @@
           <a:p>
             <a:r>
               <a:rPr lang="en-US" dirty="0"/>
-              <a:t>This is the whole of visibility in one slide, deliberately: trace it, and price it whole. The left side is the allocation chain — tag, allocate, showback, divide by a unit — and the single number to commit to is under 5% unallocated, reported weekly. That is the target that makes everything else on this slide possible. The right side is the point most cost conversations miss, and it is worth slowing down for: an AI feature gets quoted at its token cost, but it runs on compute, databases, cache, storage, gateway and log ingestion that bill every month regardless of how heavily the model is called. A project priced at its model line alone will be wrong by the size of everything under it, and the surprise arrives at the first full month, not the pilot. The instruction is the bottom bar: one ApplicationID across every resource a project touches. That is a tagging decision, not an engineering project, and it is the single most impactful thing this room can approve today.</a:t>
+              <a:t>Visibility is not a control — this slide is the controls, and the two columns are the only two moments a cost can be changed. Shift left is a change in when the conversation happens, not a tool purchase: FinOps in the design and intake conversation, understanding what a project needs before the architecture is set. Most of a workload's lifetime cost is settled at that point — rightsizing afterwards trims the margin, the design set the base. The runtime column is ordered by speed on purpose. Quotas act in seconds and are the only thing here that can stop money being spent while it is happening; alerts and budget thresholds act on a slower clock and only ever notify. Say the quote at the bottom plainly — billing data arrives a day or two late, so anything built on it can only report, never prevent. If asked what this costs: someone's time in design reviews, and reversible technical settings. No new tooling is implied by either column.</a:t>
             </a:r>
             <a:endParaRPr lang="en-US" dirty="0"/>
           </a:p>
@@ -770,7 +769,7 @@
           <a:p>
             <a:r>
               <a:rPr lang="en-US" dirty="0"/>
-              <a:t>Visibility is not a control — this slide is the controls, and the two columns are the only two moments a cost can be changed. Shift left is a change in when the conversation happens, not a tool purchase: FinOps in the design and intake conversation, understanding what a project needs before the architecture is set. Most of a workload's lifetime cost is settled at that point — rightsizing afterwards trims the margin, the design set the base. The runtime column is ordered by speed on purpose. Quotas act in seconds and are the only thing here that can stop money being spent while it is happening; alerts and budget thresholds act on a slower clock and only ever notify. Say the quote at the bottom plainly — billing data arrives a day or two late, so anything built on it can only report, never prevent. If asked what this costs: someone's time in design reviews, and reversible technical settings. No new tooling is implied by either column.</a:t>
+              <a:t>Land the plane on specifics. Ninety days, three phases, each one word — name it, see it, hold it — mapping directly back to the vision statement on slide 1. Nothing in the plan requires a purchase or new headcount, and the closing line says so explicitly because that is the first thing being calculated while this slide is on screen. The KPI panel is what makes this reportable next quarter, and none of the three is a savings number — allocation coverage says whether the data can be trusted, time-to-attribute says whether we can act, cost per unit says whether growth is healthy. Do not leave the room without the two decisions on the right. The second is the one people avoid — a limit that never blocks anything is treated as advisory, because it is. Ask directly whether we are willing to have a hard ceiling somewhere, and where. If asked about tooling: it is deliberately absent from this plan. A platform is worth evaluating once allocation cannot be fixed at source — that conversation comes after these ninety days, not instead of them.</a:t>
             </a:r>
             <a:endParaRPr lang="en-US" dirty="0"/>
           </a:p>
@@ -794,94 +793,6 @@
             <a:fld id="{F7021451-1387-4CA6-816F-3879F97B5CBC}" type="slidenum">
               <a:rPr lang="en-US"/>
               <a:t>4</a:t>
-            </a:fld>
-            <a:endParaRPr lang="en-US"/>
-          </a:p>
-        </p:txBody>
-      </p:sp>
-    </p:spTree>
-    <p:extLst>
-      <p:ext uri="{BB962C8B-B14F-4D97-AF65-F5344CB8AC3E}">
-        <p14:creationId xmlns:p14="http://schemas.microsoft.com/office/powerpoint/2010/main" val="1024086991"/>
-      </p:ext>
-    </p:extLst>
-  </p:cSld>
-  <p:clrMapOvr>
-    <a:masterClrMapping/>
-  </p:clrMapOvr>
-</p:notes>
-</file>
-
-<file path=ppt/notesSlides/notesSlide5.xml><?xml version="1.0" encoding="utf-8"?>
-<p:notes xmlns:a="http://schemas.openxmlformats.org/drawingml/2006/main" xmlns:r="http://schemas.openxmlformats.org/officeDocument/2006/relationships" xmlns:p="http://schemas.openxmlformats.org/presentationml/2006/main">
-  <p:cSld>
-    <p:spTree>
-      <p:nvGrpSpPr>
-        <p:cNvPr id="1" name=""/>
-        <p:cNvGrpSpPr/>
-        <p:nvPr/>
-      </p:nvGrpSpPr>
-      <p:grpSpPr>
-        <a:xfrm>
-          <a:off x="0" y="0"/>
-          <a:ext cx="0" cy="0"/>
-          <a:chOff x="0" y="0"/>
-          <a:chExt cx="0" cy="0"/>
-        </a:xfrm>
-      </p:grpSpPr>
-      <p:sp>
-        <p:nvSpPr>
-          <p:cNvPr id="2" name="Slide Image Placeholder 1"/>
-          <p:cNvSpPr>
-            <a:spLocks noGrp="1" noRot="1" noChangeAspect="1"/>
-          </p:cNvSpPr>
-          <p:nvPr>
-            <p:ph type="sldImg"/>
-          </p:nvPr>
-        </p:nvSpPr>
-        <p:spPr/>
-      </p:sp>
-      <p:sp>
-        <p:nvSpPr>
-          <p:cNvPr id="3" name="Notes Placeholder 2"/>
-          <p:cNvSpPr>
-            <a:spLocks noGrp="1"/>
-          </p:cNvSpPr>
-          <p:nvPr>
-            <p:ph type="body" idx="1"/>
-          </p:nvPr>
-        </p:nvSpPr>
-        <p:spPr/>
-        <p:txBody>
-          <a:bodyPr/>
-          <a:lstStyle/>
-          <a:p>
-            <a:r>
-              <a:rPr lang="en-US" dirty="0"/>
-              <a:t>Land the plane on specifics. Ninety days, three phases, each one word — name it, see it, hold it — mapping directly back to the vision statement on slide 1. Nothing in the plan requires a purchase or new headcount, and the closing line says so explicitly because that is the first thing being calculated while this slide is on screen. The KPI panel is what makes this reportable next quarter, and none of the three is a savings number — allocation coverage says whether the data can be trusted, time-to-attribute says whether we can act, cost per unit says whether growth is healthy. Do not leave the room without the two decisions on the right. The second is the one people avoid — a limit that never blocks anything is treated as advisory, because it is. Ask directly whether we are willing to have a hard ceiling somewhere, and where. If asked about tooling: it is deliberately absent from this plan. A platform is worth evaluating once allocation cannot be fixed at source — that conversation comes after these ninety days, not instead of them.</a:t>
-            </a:r>
-            <a:endParaRPr lang="en-US" dirty="0"/>
-          </a:p>
-        </p:txBody>
-      </p:sp>
-      <p:sp>
-        <p:nvSpPr>
-          <p:cNvPr id="4" name="Slide Number Placeholder 3"/>
-          <p:cNvSpPr>
-            <a:spLocks noGrp="1"/>
-          </p:cNvSpPr>
-          <p:nvPr>
-            <p:ph type="sldNum" sz="quarter" idx="10"/>
-          </p:nvPr>
-        </p:nvSpPr>
-        <p:spPr/>
-        <p:txBody>
-          <a:bodyPr/>
-          <a:lstStyle/>
-          <a:p>
-            <a:fld id="{F7021451-1387-4CA6-816F-3879F97B5CBC}" type="slidenum">
-              <a:rPr lang="en-US"/>
-              <a:t>5</a:t>
             </a:fld>
             <a:endParaRPr lang="en-US"/>
           </a:p>
@@ -2066,7 +1977,7 @@
                 <a:ea typeface="Calibri" pitchFamily="34" charset="-122"/>
                 <a:cs typeface="Calibri" pitchFamily="34" charset="-120"/>
               </a:rPr>
-              <a:t>WHY NOW</a:t>
+              <a:t>STEP ONE — SEE IT</a:t>
             </a:r>
             <a:endParaRPr lang="en-US" sz="1100" dirty="0"/>
           </a:p>
@@ -2105,7 +2016,7 @@
                 <a:ea typeface="Cambria" pitchFamily="34" charset="-122"/>
                 <a:cs typeface="Cambria" pitchFamily="34" charset="-120"/>
               </a:rPr>
-              <a:t>This is where the industry is already going</a:t>
+              <a:t>One number per project, with an owner on it</a:t>
             </a:r>
             <a:endParaRPr lang="en-US" sz="3100" dirty="0"/>
           </a:p>
@@ -2144,7 +2055,7 @@
                 <a:ea typeface="Calibri" pitchFamily="34" charset="-122"/>
                 <a:cs typeface="Calibri" pitchFamily="34" charset="-120"/>
               </a:rPr>
-              <a:t>FinOps Foundation, State of FinOps 2026 (n ≈ 1,500 practitioners worldwide).</a:t>
+              <a:t>Two things have to be true: the cost can be traced to someone, and the project is priced whole.</a:t>
             </a:r>
             <a:endParaRPr lang="en-US" sz="1500" dirty="0"/>
           </a:p>
@@ -2159,15 +2070,15 @@
         <p:spPr>
           <a:xfrm>
             <a:off x="548640" y="2121408"/>
-            <a:ext cx="3511296" cy="2743200"/>
+            <a:ext cx="5394960" cy="3200400"/>
           </a:xfrm>
           <a:prstGeom prst="roundRect">
             <a:avLst>
-              <a:gd name="adj" fmla="val 3000"/>
+              <a:gd name="adj" fmla="val 2571"/>
             </a:avLst>
           </a:prstGeom>
           <a:solidFill>
-            <a:srgbClr val="1F2936"/>
+            <a:srgbClr val="F1F3F6"/>
           </a:solidFill>
           <a:ln/>
         </p:spPr>
@@ -2180,8 +2091,8 @@
         </p:nvSpPr>
         <p:spPr>
           <a:xfrm>
-            <a:off x="859536" y="2377440"/>
-            <a:ext cx="2926080" cy="914400"/>
+            <a:off x="859536" y="2286000"/>
+            <a:ext cx="4572000" cy="292608"/>
           </a:xfrm>
           <a:prstGeom prst="rect">
             <a:avLst/>
@@ -2197,7 +2108,46 @@
               <a:buNone/>
             </a:pPr>
             <a:r>
-              <a:rPr lang="en-US" sz="4600" b="1" dirty="0">
+              <a:rPr lang="en-US" sz="1150" b="1" spc="160" kern="0" dirty="0">
+                <a:solidFill>
+                  <a:srgbClr val="5C6675"/>
+                </a:solidFill>
+                <a:latin typeface="Calibri" pitchFamily="34" charset="0"/>
+                <a:ea typeface="Calibri" pitchFamily="34" charset="-122"/>
+                <a:cs typeface="Calibri" pitchFamily="34" charset="-120"/>
+              </a:rPr>
+              <a:t>Trace it to an owner</a:t>
+            </a:r>
+            <a:endParaRPr lang="en-US" sz="1150" dirty="0"/>
+          </a:p>
+        </p:txBody>
+      </p:sp>
+      <p:sp>
+        <p:nvSpPr>
+          <p:cNvPr id="7" name="Text 5"/>
+          <p:cNvSpPr/>
+          <p:nvPr/>
+        </p:nvSpPr>
+        <p:spPr>
+          <a:xfrm>
+            <a:off x="859536" y="2688336"/>
+            <a:ext cx="310896" cy="566928"/>
+          </a:xfrm>
+          <a:prstGeom prst="rect">
+            <a:avLst/>
+          </a:prstGeom>
+          <a:noFill/>
+          <a:ln/>
+        </p:spPr>
+        <p:txBody>
+          <a:bodyPr wrap="square" lIns="0" tIns="0" rIns="0" bIns="0" rtlCol="0" anchor="t"/>
+          <a:lstStyle/>
+          <a:p>
+            <a:pPr indent="0" marL="0">
+              <a:buNone/>
+            </a:pPr>
+            <a:r>
+              <a:rPr lang="en-US" sz="1500" b="1" dirty="0">
                 <a:solidFill>
                   <a:srgbClr val="E39B2C"/>
                 </a:solidFill>
@@ -2205,22 +2155,22 @@
                 <a:ea typeface="Cambria" pitchFamily="34" charset="-122"/>
                 <a:cs typeface="Cambria" pitchFamily="34" charset="-120"/>
               </a:rPr>
-              <a:t>78%</a:t>
-            </a:r>
-            <a:endParaRPr lang="en-US" sz="4600" dirty="0"/>
-          </a:p>
-        </p:txBody>
-      </p:sp>
-      <p:sp>
-        <p:nvSpPr>
-          <p:cNvPr id="7" name="Text 5"/>
-          <p:cNvSpPr/>
-          <p:nvPr/>
-        </p:nvSpPr>
-        <p:spPr>
-          <a:xfrm>
-            <a:off x="859536" y="3364992"/>
-            <a:ext cx="2926080" cy="914400"/>
+              <a:t>1</a:t>
+            </a:r>
+            <a:endParaRPr lang="en-US" sz="1500" dirty="0"/>
+          </a:p>
+        </p:txBody>
+      </p:sp>
+      <p:sp>
+        <p:nvSpPr>
+          <p:cNvPr id="8" name="Text 6"/>
+          <p:cNvSpPr/>
+          <p:nvPr/>
+        </p:nvSpPr>
+        <p:spPr>
+          <a:xfrm>
+            <a:off x="1225296" y="2688336"/>
+            <a:ext cx="4407408" cy="621792"/>
           </a:xfrm>
           <a:prstGeom prst="rect">
             <a:avLst/>
@@ -2234,35 +2184,55 @@
           <a:p>
             <a:pPr indent="0" marL="0">
               <a:lnSpc>
-                <a:spcPts val="1900"/>
+                <a:spcPts val="1600"/>
               </a:lnSpc>
               <a:buNone/>
             </a:pPr>
             <a:r>
-              <a:rPr lang="en-US" sz="1400" dirty="0">
-                <a:solidFill>
-                  <a:srgbClr val="FFFFFF"/>
-                </a:solidFill>
-                <a:latin typeface="Calibri" pitchFamily="34" charset="0"/>
-                <a:ea typeface="Calibri" pitchFamily="34" charset="-122"/>
-                <a:cs typeface="Calibri" pitchFamily="34" charset="-120"/>
-              </a:rPr>
-              <a:t>of FinOps practices now report into the CTO/CIO organization</a:t>
-            </a:r>
-            <a:endParaRPr lang="en-US" sz="1400" dirty="0"/>
-          </a:p>
-        </p:txBody>
-      </p:sp>
-      <p:sp>
-        <p:nvSpPr>
-          <p:cNvPr id="8" name="Text 6"/>
-          <p:cNvSpPr/>
-          <p:nvPr/>
-        </p:nvSpPr>
-        <p:spPr>
-          <a:xfrm>
-            <a:off x="859536" y="4297680"/>
-            <a:ext cx="2926080" cy="457200"/>
+              <a:rPr lang="en-US" sz="1250" b="1" dirty="0">
+                <a:solidFill>
+                  <a:srgbClr val="1B2430"/>
+                </a:solidFill>
+                <a:latin typeface="Calibri" pitchFamily="34" charset="0"/>
+                <a:ea typeface="Calibri" pitchFamily="34" charset="-122"/>
+                <a:cs typeface="Calibri" pitchFamily="34" charset="-120"/>
+              </a:rPr>
+              <a:t>Tag at creation</a:t>
+            </a:r>
+            <a:endParaRPr lang="en-US" sz="1250" dirty="0"/>
+          </a:p>
+          <a:p>
+            <a:pPr indent="0" marL="0">
+              <a:lnSpc>
+                <a:spcPts val="1600"/>
+              </a:lnSpc>
+              <a:buNone/>
+            </a:pPr>
+            <a:r>
+              <a:rPr lang="en-US" sz="1250" dirty="0">
+                <a:solidFill>
+                  <a:srgbClr val="5C6675"/>
+                </a:solidFill>
+                <a:latin typeface="Calibri" pitchFamily="34" charset="0"/>
+                <a:ea typeface="Calibri" pitchFamily="34" charset="-122"/>
+                <a:cs typeface="Calibri" pitchFamily="34" charset="-120"/>
+              </a:rPr>
+              <a:t>Five tags, enforced by policy. Untagged means undeployed.</a:t>
+            </a:r>
+            <a:endParaRPr lang="en-US" sz="1250" dirty="0"/>
+          </a:p>
+        </p:txBody>
+      </p:sp>
+      <p:sp>
+        <p:nvSpPr>
+          <p:cNvPr id="9" name="Text 7"/>
+          <p:cNvSpPr/>
+          <p:nvPr/>
+        </p:nvSpPr>
+        <p:spPr>
+          <a:xfrm>
+            <a:off x="859536" y="3328416"/>
+            <a:ext cx="310896" cy="566928"/>
           </a:xfrm>
           <a:prstGeom prst="rect">
             <a:avLst/>
@@ -2275,84 +2245,82 @@
           <a:lstStyle/>
           <a:p>
             <a:pPr indent="0" marL="0">
-              <a:lnSpc>
-                <a:spcPts val="1500"/>
-              </a:lnSpc>
-              <a:buNone/>
-            </a:pPr>
-            <a:r>
-              <a:rPr lang="en-US" sz="1150" dirty="0">
-                <a:solidFill>
-                  <a:srgbClr val="9EABBA"/>
-                </a:solidFill>
-                <a:latin typeface="Calibri" pitchFamily="34" charset="0"/>
-                <a:ea typeface="Calibri" pitchFamily="34" charset="-122"/>
-                <a:cs typeface="Calibri" pitchFamily="34" charset="-120"/>
-              </a:rPr>
-              <a:t>up 18 points since 2023</a:t>
-            </a:r>
-            <a:endParaRPr lang="en-US" sz="1150" dirty="0"/>
-          </a:p>
-        </p:txBody>
-      </p:sp>
-      <p:sp>
-        <p:nvSpPr>
-          <p:cNvPr id="9" name="Shape 7"/>
-          <p:cNvSpPr/>
-          <p:nvPr/>
-        </p:nvSpPr>
-        <p:spPr>
-          <a:xfrm>
-            <a:off x="4334256" y="2121408"/>
-            <a:ext cx="3511296" cy="2743200"/>
-          </a:xfrm>
-          <a:prstGeom prst="roundRect">
-            <a:avLst>
-              <a:gd name="adj" fmla="val 3000"/>
-            </a:avLst>
-          </a:prstGeom>
-          <a:solidFill>
-            <a:srgbClr val="DDEDE9"/>
-          </a:solidFill>
-          <a:ln/>
-        </p:spPr>
-      </p:sp>
-      <p:sp>
-        <p:nvSpPr>
-          <p:cNvPr id="10" name="Text 8"/>
-          <p:cNvSpPr/>
-          <p:nvPr/>
-        </p:nvSpPr>
-        <p:spPr>
-          <a:xfrm>
-            <a:off x="4645152" y="2377440"/>
-            <a:ext cx="2926080" cy="914400"/>
-          </a:xfrm>
-          <a:prstGeom prst="rect">
-            <a:avLst/>
-          </a:prstGeom>
-          <a:noFill/>
-          <a:ln/>
-        </p:spPr>
-        <p:txBody>
-          <a:bodyPr wrap="square" lIns="0" tIns="0" rIns="0" bIns="0" rtlCol="0" anchor="ctr"/>
-          <a:lstStyle/>
-          <a:p>
-            <a:pPr indent="0" marL="0">
-              <a:buNone/>
-            </a:pPr>
-            <a:r>
-              <a:rPr lang="en-US" sz="4600" b="1" dirty="0">
-                <a:solidFill>
-                  <a:srgbClr val="1F6B5C"/>
+              <a:buNone/>
+            </a:pPr>
+            <a:r>
+              <a:rPr lang="en-US" sz="1500" b="1" dirty="0">
+                <a:solidFill>
+                  <a:srgbClr val="E39B2C"/>
                 </a:solidFill>
                 <a:latin typeface="Cambria" pitchFamily="34" charset="0"/>
                 <a:ea typeface="Cambria" pitchFamily="34" charset="-122"/>
                 <a:cs typeface="Cambria" pitchFamily="34" charset="-120"/>
               </a:rPr>
-              <a:t>98%</a:t>
-            </a:r>
-            <a:endParaRPr lang="en-US" sz="4600" dirty="0"/>
+              <a:t>2</a:t>
+            </a:r>
+            <a:endParaRPr lang="en-US" sz="1500" dirty="0"/>
+          </a:p>
+        </p:txBody>
+      </p:sp>
+      <p:sp>
+        <p:nvSpPr>
+          <p:cNvPr id="10" name="Text 8"/>
+          <p:cNvSpPr/>
+          <p:nvPr/>
+        </p:nvSpPr>
+        <p:spPr>
+          <a:xfrm>
+            <a:off x="1225296" y="3328416"/>
+            <a:ext cx="4407408" cy="621792"/>
+          </a:xfrm>
+          <a:prstGeom prst="rect">
+            <a:avLst/>
+          </a:prstGeom>
+          <a:noFill/>
+          <a:ln/>
+        </p:spPr>
+        <p:txBody>
+          <a:bodyPr wrap="square" lIns="0" tIns="0" rIns="0" bIns="0" rtlCol="0" anchor="t"/>
+          <a:lstStyle/>
+          <a:p>
+            <a:pPr indent="0" marL="0">
+              <a:lnSpc>
+                <a:spcPts val="1600"/>
+              </a:lnSpc>
+              <a:buNone/>
+            </a:pPr>
+            <a:r>
+              <a:rPr lang="en-US" sz="1250" b="1" dirty="0">
+                <a:solidFill>
+                  <a:srgbClr val="1B2430"/>
+                </a:solidFill>
+                <a:latin typeface="Calibri" pitchFamily="34" charset="0"/>
+                <a:ea typeface="Calibri" pitchFamily="34" charset="-122"/>
+                <a:cs typeface="Calibri" pitchFamily="34" charset="-120"/>
+              </a:rPr>
+              <a:t>Allocate the spend</a:t>
+            </a:r>
+            <a:endParaRPr lang="en-US" sz="1250" dirty="0"/>
+          </a:p>
+          <a:p>
+            <a:pPr indent="0" marL="0">
+              <a:lnSpc>
+                <a:spcPts val="1600"/>
+              </a:lnSpc>
+              <a:buNone/>
+            </a:pPr>
+            <a:r>
+              <a:rPr lang="en-US" sz="1250" dirty="0">
+                <a:solidFill>
+                  <a:srgbClr val="5C6675"/>
+                </a:solidFill>
+                <a:latin typeface="Calibri" pitchFamily="34" charset="0"/>
+                <a:ea typeface="Calibri" pitchFamily="34" charset="-122"/>
+                <a:cs typeface="Calibri" pitchFamily="34" charset="-120"/>
+              </a:rPr>
+              <a:t>Target under 5% unallocated, reported weekly.</a:t>
+            </a:r>
+            <a:endParaRPr lang="en-US" sz="1250" dirty="0"/>
           </a:p>
         </p:txBody>
       </p:sp>
@@ -2364,8 +2332,8 @@
         </p:nvSpPr>
         <p:spPr>
           <a:xfrm>
-            <a:off x="4645152" y="3364992"/>
-            <a:ext cx="2926080" cy="914400"/>
+            <a:off x="859536" y="3968496"/>
+            <a:ext cx="310896" cy="566928"/>
           </a:xfrm>
           <a:prstGeom prst="rect">
             <a:avLst/>
@@ -2378,139 +2346,33 @@
           <a:lstStyle/>
           <a:p>
             <a:pPr indent="0" marL="0">
-              <a:lnSpc>
-                <a:spcPts val="1900"/>
-              </a:lnSpc>
-              <a:buNone/>
-            </a:pPr>
-            <a:r>
-              <a:rPr lang="en-US" sz="1400" dirty="0">
-                <a:solidFill>
-                  <a:srgbClr val="1B2430"/>
-                </a:solidFill>
-                <a:latin typeface="Calibri" pitchFamily="34" charset="0"/>
-                <a:ea typeface="Calibri" pitchFamily="34" charset="-122"/>
-                <a:cs typeface="Calibri" pitchFamily="34" charset="-120"/>
-              </a:rPr>
-              <a:t>of practices now manage AI spend as a core operating cost</a:t>
-            </a:r>
-            <a:endParaRPr lang="en-US" sz="1400" dirty="0"/>
-          </a:p>
-        </p:txBody>
-      </p:sp>
-      <p:sp>
-        <p:nvSpPr>
-          <p:cNvPr id="12" name="Text 10"/>
-          <p:cNvSpPr/>
-          <p:nvPr/>
-        </p:nvSpPr>
-        <p:spPr>
-          <a:xfrm>
-            <a:off x="4645152" y="4297680"/>
-            <a:ext cx="2926080" cy="457200"/>
-          </a:xfrm>
-          <a:prstGeom prst="rect">
-            <a:avLst/>
-          </a:prstGeom>
-          <a:noFill/>
-          <a:ln/>
-        </p:spPr>
-        <p:txBody>
-          <a:bodyPr wrap="square" lIns="0" tIns="0" rIns="0" bIns="0" rtlCol="0" anchor="t"/>
-          <a:lstStyle/>
-          <a:p>
-            <a:pPr indent="0" marL="0">
-              <a:lnSpc>
-                <a:spcPts val="1500"/>
-              </a:lnSpc>
-              <a:buNone/>
-            </a:pPr>
-            <a:r>
-              <a:rPr lang="en-US" sz="1150" dirty="0">
-                <a:solidFill>
-                  <a:srgbClr val="5C6675"/>
-                </a:solidFill>
-                <a:latin typeface="Calibri" pitchFamily="34" charset="0"/>
-                <a:ea typeface="Calibri" pitchFamily="34" charset="-122"/>
-                <a:cs typeface="Calibri" pitchFamily="34" charset="-120"/>
-              </a:rPr>
-              <a:t>SaaS 90% · licensing 64% · data centre 48%</a:t>
-            </a:r>
-            <a:endParaRPr lang="en-US" sz="1150" dirty="0"/>
-          </a:p>
-        </p:txBody>
-      </p:sp>
-      <p:sp>
-        <p:nvSpPr>
-          <p:cNvPr id="13" name="Shape 11"/>
-          <p:cNvSpPr/>
-          <p:nvPr/>
-        </p:nvSpPr>
-        <p:spPr>
-          <a:xfrm>
-            <a:off x="8119872" y="2121408"/>
-            <a:ext cx="3511296" cy="2743200"/>
-          </a:xfrm>
-          <a:prstGeom prst="roundRect">
-            <a:avLst>
-              <a:gd name="adj" fmla="val 3000"/>
-            </a:avLst>
-          </a:prstGeom>
-          <a:solidFill>
-            <a:srgbClr val="FBEFD8"/>
-          </a:solidFill>
-          <a:ln/>
-        </p:spPr>
-      </p:sp>
-      <p:sp>
-        <p:nvSpPr>
-          <p:cNvPr id="14" name="Text 12"/>
-          <p:cNvSpPr/>
-          <p:nvPr/>
-        </p:nvSpPr>
-        <p:spPr>
-          <a:xfrm>
-            <a:off x="8430768" y="2377440"/>
-            <a:ext cx="2926080" cy="914400"/>
-          </a:xfrm>
-          <a:prstGeom prst="rect">
-            <a:avLst/>
-          </a:prstGeom>
-          <a:noFill/>
-          <a:ln/>
-        </p:spPr>
-        <p:txBody>
-          <a:bodyPr wrap="square" lIns="0" tIns="0" rIns="0" bIns="0" rtlCol="0" anchor="ctr"/>
-          <a:lstStyle/>
-          <a:p>
-            <a:pPr indent="0" marL="0">
-              <a:buNone/>
-            </a:pPr>
-            <a:r>
-              <a:rPr lang="en-US" sz="4600" b="1" dirty="0">
-                <a:solidFill>
-                  <a:srgbClr val="B87B18"/>
+              <a:buNone/>
+            </a:pPr>
+            <a:r>
+              <a:rPr lang="en-US" sz="1500" b="1" dirty="0">
+                <a:solidFill>
+                  <a:srgbClr val="E39B2C"/>
                 </a:solidFill>
                 <a:latin typeface="Cambria" pitchFamily="34" charset="0"/>
                 <a:ea typeface="Cambria" pitchFamily="34" charset="-122"/>
                 <a:cs typeface="Cambria" pitchFamily="34" charset="-120"/>
               </a:rPr>
-              <a:t>#3</a:t>
-            </a:r>
-            <a:endParaRPr lang="en-US" sz="4600" dirty="0"/>
-          </a:p>
-        </p:txBody>
-      </p:sp>
-      <p:sp>
-        <p:nvSpPr>
-          <p:cNvPr id="15" name="Text 13"/>
-          <p:cNvSpPr/>
-          <p:nvPr/>
-        </p:nvSpPr>
-        <p:spPr>
-          <a:xfrm>
-            <a:off x="8430768" y="3364992"/>
-            <a:ext cx="2926080" cy="914400"/>
+              <a:t>3</a:t>
+            </a:r>
+            <a:endParaRPr lang="en-US" sz="1500" dirty="0"/>
+          </a:p>
+        </p:txBody>
+      </p:sp>
+      <p:sp>
+        <p:nvSpPr>
+          <p:cNvPr id="12" name="Text 10"/>
+          <p:cNvSpPr/>
+          <p:nvPr/>
+        </p:nvSpPr>
+        <p:spPr>
+          <a:xfrm>
+            <a:off x="1225296" y="3968496"/>
+            <a:ext cx="4407408" cy="621792"/>
           </a:xfrm>
           <a:prstGeom prst="rect">
             <a:avLst/>
@@ -2524,12 +2386,12 @@
           <a:p>
             <a:pPr indent="0" marL="0">
               <a:lnSpc>
-                <a:spcPts val="1900"/>
+                <a:spcPts val="1600"/>
               </a:lnSpc>
               <a:buNone/>
             </a:pPr>
             <a:r>
-              <a:rPr lang="en-US" sz="1400" dirty="0">
+              <a:rPr lang="en-US" sz="1250" b="1" dirty="0">
                 <a:solidFill>
                   <a:srgbClr val="1B2430"/>
                 </a:solidFill>
@@ -2537,22 +2399,42 @@
                 <a:ea typeface="Calibri" pitchFamily="34" charset="-122"/>
                 <a:cs typeface="Calibri" pitchFamily="34" charset="-120"/>
               </a:rPr>
-              <a:t>governance ranks above optimization in 2026 priorities</a:t>
-            </a:r>
-            <a:endParaRPr lang="en-US" sz="1400" dirty="0"/>
-          </a:p>
-        </p:txBody>
-      </p:sp>
-      <p:sp>
-        <p:nvSpPr>
-          <p:cNvPr id="16" name="Text 14"/>
-          <p:cNvSpPr/>
-          <p:nvPr/>
-        </p:nvSpPr>
-        <p:spPr>
-          <a:xfrm>
-            <a:off x="8430768" y="4297680"/>
-            <a:ext cx="2926080" cy="457200"/>
+              <a:t>Show teams their own numbers</a:t>
+            </a:r>
+            <a:endParaRPr lang="en-US" sz="1250" dirty="0"/>
+          </a:p>
+          <a:p>
+            <a:pPr indent="0" marL="0">
+              <a:lnSpc>
+                <a:spcPts val="1600"/>
+              </a:lnSpc>
+              <a:buNone/>
+            </a:pPr>
+            <a:r>
+              <a:rPr lang="en-US" sz="1250" dirty="0">
+                <a:solidFill>
+                  <a:srgbClr val="5C6675"/>
+                </a:solidFill>
+                <a:latin typeface="Calibri" pitchFamily="34" charset="0"/>
+                <a:ea typeface="Calibri" pitchFamily="34" charset="-122"/>
+                <a:cs typeface="Calibri" pitchFamily="34" charset="-120"/>
+              </a:rPr>
+              <a:t>Four to six weeks before anything is charged.</a:t>
+            </a:r>
+            <a:endParaRPr lang="en-US" sz="1250" dirty="0"/>
+          </a:p>
+        </p:txBody>
+      </p:sp>
+      <p:sp>
+        <p:nvSpPr>
+          <p:cNvPr id="13" name="Text 11"/>
+          <p:cNvSpPr/>
+          <p:nvPr/>
+        </p:nvSpPr>
+        <p:spPr>
+          <a:xfrm>
+            <a:off x="859536" y="4608576"/>
+            <a:ext cx="310896" cy="566928"/>
           </a:xfrm>
           <a:prstGeom prst="rect">
             <a:avLst/>
@@ -2565,13 +2447,72 @@
           <a:lstStyle/>
           <a:p>
             <a:pPr indent="0" marL="0">
+              <a:buNone/>
+            </a:pPr>
+            <a:r>
+              <a:rPr lang="en-US" sz="1500" b="1" dirty="0">
+                <a:solidFill>
+                  <a:srgbClr val="E39B2C"/>
+                </a:solidFill>
+                <a:latin typeface="Cambria" pitchFamily="34" charset="0"/>
+                <a:ea typeface="Cambria" pitchFamily="34" charset="-122"/>
+                <a:cs typeface="Cambria" pitchFamily="34" charset="-120"/>
+              </a:rPr>
+              <a:t>4</a:t>
+            </a:r>
+            <a:endParaRPr lang="en-US" sz="1500" dirty="0"/>
+          </a:p>
+        </p:txBody>
+      </p:sp>
+      <p:sp>
+        <p:nvSpPr>
+          <p:cNvPr id="14" name="Text 12"/>
+          <p:cNvSpPr/>
+          <p:nvPr/>
+        </p:nvSpPr>
+        <p:spPr>
+          <a:xfrm>
+            <a:off x="1225296" y="4608576"/>
+            <a:ext cx="4407408" cy="621792"/>
+          </a:xfrm>
+          <a:prstGeom prst="rect">
+            <a:avLst/>
+          </a:prstGeom>
+          <a:noFill/>
+          <a:ln/>
+        </p:spPr>
+        <p:txBody>
+          <a:bodyPr wrap="square" lIns="0" tIns="0" rIns="0" bIns="0" rtlCol="0" anchor="t"/>
+          <a:lstStyle/>
+          <a:p>
+            <a:pPr indent="0" marL="0">
               <a:lnSpc>
-                <a:spcPts val="1500"/>
+                <a:spcPts val="1600"/>
               </a:lnSpc>
               <a:buNone/>
             </a:pPr>
             <a:r>
-              <a:rPr lang="en-US" sz="1150" dirty="0">
+              <a:rPr lang="en-US" sz="1250" b="1" dirty="0">
+                <a:solidFill>
+                  <a:srgbClr val="1B2430"/>
+                </a:solidFill>
+                <a:latin typeface="Calibri" pitchFamily="34" charset="0"/>
+                <a:ea typeface="Calibri" pitchFamily="34" charset="-122"/>
+                <a:cs typeface="Calibri" pitchFamily="34" charset="-120"/>
+              </a:rPr>
+              <a:t>Divide by the unit</a:t>
+            </a:r>
+            <a:endParaRPr lang="en-US" sz="1250" dirty="0"/>
+          </a:p>
+          <a:p>
+            <a:pPr indent="0" marL="0">
+              <a:lnSpc>
+                <a:spcPts val="1600"/>
+              </a:lnSpc>
+              <a:buNone/>
+            </a:pPr>
+            <a:r>
+              <a:rPr lang="en-US" sz="1250" dirty="0">
                 <a:solidFill>
                   <a:srgbClr val="5C6675"/>
                 </a:solidFill>
@@ -2579,26 +2520,26 @@
                 <a:ea typeface="Calibri" pitchFamily="34" charset="-122"/>
                 <a:cs typeface="Calibri" pitchFamily="34" charset="-120"/>
               </a:rPr>
-              <a:t>behind only AI cost management and AI-driven efficiency</a:t>
-            </a:r>
-            <a:endParaRPr lang="en-US" sz="1150" dirty="0"/>
-          </a:p>
-        </p:txBody>
-      </p:sp>
-      <p:sp>
-        <p:nvSpPr>
-          <p:cNvPr id="17" name="Shape 15"/>
-          <p:cNvSpPr/>
-          <p:nvPr/>
-        </p:nvSpPr>
-        <p:spPr>
-          <a:xfrm>
-            <a:off x="548640" y="5084064"/>
-            <a:ext cx="11091672" cy="1536192"/>
+              <a:t>Cost per customer, per order, per conversation.</a:t>
+            </a:r>
+            <a:endParaRPr lang="en-US" sz="1250" dirty="0"/>
+          </a:p>
+        </p:txBody>
+      </p:sp>
+      <p:sp>
+        <p:nvSpPr>
+          <p:cNvPr id="15" name="Shape 13"/>
+          <p:cNvSpPr/>
+          <p:nvPr/>
+        </p:nvSpPr>
+        <p:spPr>
+          <a:xfrm>
+            <a:off x="6245352" y="2121408"/>
+            <a:ext cx="5394960" cy="3200400"/>
           </a:xfrm>
           <a:prstGeom prst="roundRect">
             <a:avLst>
-              <a:gd name="adj" fmla="val 5357"/>
+              <a:gd name="adj" fmla="val 2571"/>
             </a:avLst>
           </a:prstGeom>
           <a:solidFill>
@@ -2616,14 +2557,14 @@
       </p:sp>
       <p:sp>
         <p:nvSpPr>
-          <p:cNvPr id="18" name="Text 16"/>
-          <p:cNvSpPr/>
-          <p:nvPr/>
-        </p:nvSpPr>
-        <p:spPr>
-          <a:xfrm>
-            <a:off x="877824" y="5248656"/>
-            <a:ext cx="7315200" cy="292608"/>
+          <p:cNvPr id="16" name="Text 14"/>
+          <p:cNvSpPr/>
+          <p:nvPr/>
+        </p:nvSpPr>
+        <p:spPr>
+          <a:xfrm>
+            <a:off x="6556248" y="2286000"/>
+            <a:ext cx="4572000" cy="292608"/>
           </a:xfrm>
           <a:prstGeom prst="rect">
             <a:avLst/>
@@ -2647,7 +2588,7 @@
                 <a:ea typeface="Calibri" pitchFamily="34" charset="-122"/>
                 <a:cs typeface="Calibri" pitchFamily="34" charset="-120"/>
               </a:rPr>
-              <a:t>What it means for this organization</a:t>
+              <a:t>Price the project whole</a:t>
             </a:r>
             <a:endParaRPr lang="en-US" sz="1150" dirty="0"/>
           </a:p>
@@ -2655,14 +2596,78 @@
       </p:sp>
       <p:sp>
         <p:nvSpPr>
+          <p:cNvPr id="17" name="Text 15"/>
+          <p:cNvSpPr/>
+          <p:nvPr/>
+        </p:nvSpPr>
+        <p:spPr>
+          <a:xfrm>
+            <a:off x="6556248" y="2615184"/>
+            <a:ext cx="4773168" cy="457200"/>
+          </a:xfrm>
+          <a:prstGeom prst="rect">
+            <a:avLst/>
+          </a:prstGeom>
+          <a:noFill/>
+          <a:ln/>
+        </p:spPr>
+        <p:txBody>
+          <a:bodyPr wrap="square" lIns="0" tIns="0" rIns="0" bIns="0" rtlCol="0" anchor="t"/>
+          <a:lstStyle/>
+          <a:p>
+            <a:pPr indent="0" marL="0">
+              <a:lnSpc>
+                <a:spcPts val="1700"/>
+              </a:lnSpc>
+              <a:buNone/>
+            </a:pPr>
+            <a:r>
+              <a:rPr lang="en-US" sz="1250" dirty="0">
+                <a:solidFill>
+                  <a:srgbClr val="9EABBA"/>
+                </a:solidFill>
+                <a:latin typeface="Calibri" pitchFamily="34" charset="0"/>
+                <a:ea typeface="Calibri" pitchFamily="34" charset="-122"/>
+                <a:cs typeface="Calibri" pitchFamily="34" charset="-120"/>
+              </a:rPr>
+              <a:t>An AI feature is quoted at its token cost. It runs on a stack that bills every month regardless.</a:t>
+            </a:r>
+            <a:endParaRPr lang="en-US" sz="1250" dirty="0"/>
+          </a:p>
+        </p:txBody>
+      </p:sp>
+      <p:sp>
+        <p:nvSpPr>
+          <p:cNvPr id="18" name="Shape 16"/>
+          <p:cNvSpPr/>
+          <p:nvPr/>
+        </p:nvSpPr>
+        <p:spPr>
+          <a:xfrm>
+            <a:off x="6556248" y="3291840"/>
+            <a:ext cx="82296" cy="274320"/>
+          </a:xfrm>
+          <a:prstGeom prst="roundRect">
+            <a:avLst>
+              <a:gd name="adj" fmla="val 44444"/>
+            </a:avLst>
+          </a:prstGeom>
+          <a:solidFill>
+            <a:srgbClr val="E39B2C"/>
+          </a:solidFill>
+          <a:ln/>
+        </p:spPr>
+      </p:sp>
+      <p:sp>
+        <p:nvSpPr>
           <p:cNvPr id="19" name="Text 17"/>
           <p:cNvSpPr/>
           <p:nvPr/>
         </p:nvSpPr>
         <p:spPr>
           <a:xfrm>
-            <a:off x="877824" y="5577840"/>
-            <a:ext cx="10424160" cy="960120"/>
+            <a:off x="6766560" y="3200400"/>
+            <a:ext cx="4572000" cy="512064"/>
           </a:xfrm>
           <a:prstGeom prst="rect">
             <a:avLst/>
@@ -2676,37 +2681,328 @@
           <a:p>
             <a:pPr indent="0" marL="0">
               <a:lnSpc>
-                <a:spcPts val="2000"/>
+                <a:spcPts val="1600"/>
               </a:lnSpc>
               <a:buNone/>
             </a:pPr>
             <a:r>
+              <a:rPr lang="en-US" sz="1250" b="1" dirty="0">
+                <a:solidFill>
+                  <a:srgbClr val="E39B2C"/>
+                </a:solidFill>
+                <a:latin typeface="Calibri" pitchFamily="34" charset="0"/>
+                <a:ea typeface="Calibri" pitchFamily="34" charset="-122"/>
+                <a:cs typeface="Calibri" pitchFamily="34" charset="-120"/>
+              </a:rPr>
+              <a:t>Model / tokens</a:t>
+            </a:r>
+            <a:endParaRPr lang="en-US" sz="1250" dirty="0"/>
+          </a:p>
+          <a:p>
+            <a:pPr indent="0" marL="0">
+              <a:lnSpc>
+                <a:spcPts val="1600"/>
+              </a:lnSpc>
+              <a:buNone/>
+            </a:pPr>
+            <a:r>
+              <a:rPr lang="en-US" sz="1250" dirty="0">
+                <a:solidFill>
+                  <a:srgbClr val="9EABBA"/>
+                </a:solidFill>
+                <a:latin typeface="Calibri" pitchFamily="34" charset="0"/>
+                <a:ea typeface="Calibri" pitchFamily="34" charset="-122"/>
+                <a:cs typeface="Calibri" pitchFamily="34" charset="-120"/>
+              </a:rPr>
+              <a:t>the line everyone quotes</a:t>
+            </a:r>
+            <a:endParaRPr lang="en-US" sz="1250" dirty="0"/>
+          </a:p>
+        </p:txBody>
+      </p:sp>
+      <p:sp>
+        <p:nvSpPr>
+          <p:cNvPr id="20" name="Shape 18"/>
+          <p:cNvSpPr/>
+          <p:nvPr/>
+        </p:nvSpPr>
+        <p:spPr>
+          <a:xfrm>
+            <a:off x="6556248" y="3858768"/>
+            <a:ext cx="82296" cy="274320"/>
+          </a:xfrm>
+          <a:prstGeom prst="roundRect">
+            <a:avLst>
+              <a:gd name="adj" fmla="val 44444"/>
+            </a:avLst>
+          </a:prstGeom>
+          <a:solidFill>
+            <a:srgbClr val="8C9AAC"/>
+          </a:solidFill>
+          <a:ln/>
+        </p:spPr>
+      </p:sp>
+      <p:sp>
+        <p:nvSpPr>
+          <p:cNvPr id="21" name="Text 19"/>
+          <p:cNvSpPr/>
+          <p:nvPr/>
+        </p:nvSpPr>
+        <p:spPr>
+          <a:xfrm>
+            <a:off x="6766560" y="3767328"/>
+            <a:ext cx="4572000" cy="512064"/>
+          </a:xfrm>
+          <a:prstGeom prst="rect">
+            <a:avLst/>
+          </a:prstGeom>
+          <a:noFill/>
+          <a:ln/>
+        </p:spPr>
+        <p:txBody>
+          <a:bodyPr wrap="square" lIns="0" tIns="0" rIns="0" bIns="0" rtlCol="0" anchor="t"/>
+          <a:lstStyle/>
+          <a:p>
+            <a:pPr indent="0" marL="0">
+              <a:lnSpc>
+                <a:spcPts val="1600"/>
+              </a:lnSpc>
+              <a:buNone/>
+            </a:pPr>
+            <a:r>
+              <a:rPr lang="en-US" sz="1250" b="1" dirty="0">
+                <a:solidFill>
+                  <a:srgbClr val="FFFFFF"/>
+                </a:solidFill>
+                <a:latin typeface="Calibri" pitchFamily="34" charset="0"/>
+                <a:ea typeface="Calibri" pitchFamily="34" charset="-122"/>
+                <a:cs typeface="Calibri" pitchFamily="34" charset="-120"/>
+              </a:rPr>
+              <a:t>Compute, databases, cache</a:t>
+            </a:r>
+            <a:endParaRPr lang="en-US" sz="1250" dirty="0"/>
+          </a:p>
+          <a:p>
+            <a:pPr indent="0" marL="0">
+              <a:lnSpc>
+                <a:spcPts val="1600"/>
+              </a:lnSpc>
+              <a:buNone/>
+            </a:pPr>
+            <a:r>
+              <a:rPr lang="en-US" sz="1250" dirty="0">
+                <a:solidFill>
+                  <a:srgbClr val="9EABBA"/>
+                </a:solidFill>
+                <a:latin typeface="Calibri" pitchFamily="34" charset="0"/>
+                <a:ea typeface="Calibri" pitchFamily="34" charset="-122"/>
+                <a:cs typeface="Calibri" pitchFamily="34" charset="-120"/>
+              </a:rPr>
+              <a:t>app services, SQL, Redis, queues</a:t>
+            </a:r>
+            <a:endParaRPr lang="en-US" sz="1250" dirty="0"/>
+          </a:p>
+        </p:txBody>
+      </p:sp>
+      <p:sp>
+        <p:nvSpPr>
+          <p:cNvPr id="22" name="Shape 20"/>
+          <p:cNvSpPr/>
+          <p:nvPr/>
+        </p:nvSpPr>
+        <p:spPr>
+          <a:xfrm>
+            <a:off x="6556248" y="4425696"/>
+            <a:ext cx="82296" cy="274320"/>
+          </a:xfrm>
+          <a:prstGeom prst="roundRect">
+            <a:avLst>
+              <a:gd name="adj" fmla="val 44444"/>
+            </a:avLst>
+          </a:prstGeom>
+          <a:solidFill>
+            <a:srgbClr val="8C9AAC"/>
+          </a:solidFill>
+          <a:ln/>
+        </p:spPr>
+      </p:sp>
+      <p:sp>
+        <p:nvSpPr>
+          <p:cNvPr id="23" name="Text 21"/>
+          <p:cNvSpPr/>
+          <p:nvPr/>
+        </p:nvSpPr>
+        <p:spPr>
+          <a:xfrm>
+            <a:off x="6766560" y="4334256"/>
+            <a:ext cx="4572000" cy="512064"/>
+          </a:xfrm>
+          <a:prstGeom prst="rect">
+            <a:avLst/>
+          </a:prstGeom>
+          <a:noFill/>
+          <a:ln/>
+        </p:spPr>
+        <p:txBody>
+          <a:bodyPr wrap="square" lIns="0" tIns="0" rIns="0" bIns="0" rtlCol="0" anchor="t"/>
+          <a:lstStyle/>
+          <a:p>
+            <a:pPr indent="0" marL="0">
+              <a:lnSpc>
+                <a:spcPts val="1600"/>
+              </a:lnSpc>
+              <a:buNone/>
+            </a:pPr>
+            <a:r>
+              <a:rPr lang="en-US" sz="1250" b="1" dirty="0">
+                <a:solidFill>
+                  <a:srgbClr val="FFFFFF"/>
+                </a:solidFill>
+                <a:latin typeface="Calibri" pitchFamily="34" charset="0"/>
+                <a:ea typeface="Calibri" pitchFamily="34" charset="-122"/>
+                <a:cs typeface="Calibri" pitchFamily="34" charset="-120"/>
+              </a:rPr>
+              <a:t>Storage, network, observability</a:t>
+            </a:r>
+            <a:endParaRPr lang="en-US" sz="1250" dirty="0"/>
+          </a:p>
+          <a:p>
+            <a:pPr indent="0" marL="0">
+              <a:lnSpc>
+                <a:spcPts val="1600"/>
+              </a:lnSpc>
+              <a:buNone/>
+            </a:pPr>
+            <a:r>
+              <a:rPr lang="en-US" sz="1250" dirty="0">
+                <a:solidFill>
+                  <a:srgbClr val="9EABBA"/>
+                </a:solidFill>
+                <a:latin typeface="Calibri" pitchFamily="34" charset="0"/>
+                <a:ea typeface="Calibri" pitchFamily="34" charset="-122"/>
+                <a:cs typeface="Calibri" pitchFamily="34" charset="-120"/>
+              </a:rPr>
+              <a:t>backups, egress, log ingestion</a:t>
+            </a:r>
+            <a:endParaRPr lang="en-US" sz="1250" dirty="0"/>
+          </a:p>
+        </p:txBody>
+      </p:sp>
+      <p:sp>
+        <p:nvSpPr>
+          <p:cNvPr id="24" name="Text 22"/>
+          <p:cNvSpPr/>
+          <p:nvPr/>
+        </p:nvSpPr>
+        <p:spPr>
+          <a:xfrm>
+            <a:off x="6556248" y="4901184"/>
+            <a:ext cx="4572000" cy="274320"/>
+          </a:xfrm>
+          <a:prstGeom prst="rect">
+            <a:avLst/>
+          </a:prstGeom>
+          <a:noFill/>
+          <a:ln/>
+        </p:spPr>
+        <p:txBody>
+          <a:bodyPr wrap="square" lIns="0" tIns="0" rIns="0" bIns="0" rtlCol="0" anchor="t"/>
+          <a:lstStyle/>
+          <a:p>
+            <a:pPr indent="0" marL="0">
+              <a:buNone/>
+            </a:pPr>
+            <a:r>
+              <a:rPr lang="en-US" sz="1150" i="1" dirty="0">
+                <a:solidFill>
+                  <a:srgbClr val="9EABBA"/>
+                </a:solidFill>
+                <a:latin typeface="Calibri" pitchFamily="34" charset="0"/>
+                <a:ea typeface="Calibri" pitchFamily="34" charset="-122"/>
+                <a:cs typeface="Calibri" pitchFamily="34" charset="-120"/>
+              </a:rPr>
+              <a:t>Every layer bills whether or not the model is called.</a:t>
+            </a:r>
+            <a:endParaRPr lang="en-US" sz="1150" dirty="0"/>
+          </a:p>
+        </p:txBody>
+      </p:sp>
+      <p:sp>
+        <p:nvSpPr>
+          <p:cNvPr id="25" name="Shape 23"/>
+          <p:cNvSpPr/>
+          <p:nvPr/>
+        </p:nvSpPr>
+        <p:spPr>
+          <a:xfrm>
+            <a:off x="548640" y="5504688"/>
+            <a:ext cx="11091672" cy="914400"/>
+          </a:xfrm>
+          <a:prstGeom prst="roundRect">
+            <a:avLst>
+              <a:gd name="adj" fmla="val 9000"/>
+            </a:avLst>
+          </a:prstGeom>
+          <a:solidFill>
+            <a:srgbClr val="DDEDE9"/>
+          </a:solidFill>
+          <a:ln/>
+        </p:spPr>
+      </p:sp>
+      <p:sp>
+        <p:nvSpPr>
+          <p:cNvPr id="26" name="Text 24"/>
+          <p:cNvSpPr/>
+          <p:nvPr/>
+        </p:nvSpPr>
+        <p:spPr>
+          <a:xfrm>
+            <a:off x="877824" y="5504688"/>
+            <a:ext cx="10424160" cy="914400"/>
+          </a:xfrm>
+          <a:prstGeom prst="rect">
+            <a:avLst/>
+          </a:prstGeom>
+          <a:noFill/>
+          <a:ln/>
+        </p:spPr>
+        <p:txBody>
+          <a:bodyPr wrap="square" lIns="0" tIns="0" rIns="0" bIns="0" rtlCol="0" anchor="ctr"/>
+          <a:lstStyle/>
+          <a:p>
+            <a:pPr indent="0" marL="0">
+              <a:lnSpc>
+                <a:spcPts val="1900"/>
+              </a:lnSpc>
+              <a:buNone/>
+            </a:pPr>
+            <a:r>
               <a:rPr lang="en-US" sz="1350" b="1" dirty="0">
                 <a:solidFill>
-                  <a:srgbClr val="FFFFFF"/>
-                </a:solidFill>
-                <a:latin typeface="Calibri" pitchFamily="34" charset="0"/>
-                <a:ea typeface="Calibri" pitchFamily="34" charset="-122"/>
-                <a:cs typeface="Calibri" pitchFamily="34" charset="-120"/>
-              </a:rPr>
-              <a:t>Cost control has stopped being a finance report and become a technology capability — </a:t>
+                  <a:srgbClr val="1B2430"/>
+                </a:solidFill>
+                <a:latin typeface="Calibri" pitchFamily="34" charset="0"/>
+                <a:ea typeface="Calibri" pitchFamily="34" charset="-122"/>
+                <a:cs typeface="Calibri" pitchFamily="34" charset="-120"/>
+              </a:rPr>
+              <a:t>One ApplicationID across every resource a project touches. </a:t>
             </a:r>
             <a:pPr indent="0" marL="0">
               <a:lnSpc>
-                <a:spcPts val="2000"/>
+                <a:spcPts val="1900"/>
               </a:lnSpc>
               <a:buNone/>
             </a:pPr>
             <a:r>
               <a:rPr lang="en-US" sz="1350" dirty="0">
                 <a:solidFill>
-                  <a:srgbClr val="9EABBA"/>
-                </a:solidFill>
-                <a:latin typeface="Calibri" pitchFamily="34" charset="0"/>
-                <a:ea typeface="Calibri" pitchFamily="34" charset="-122"/>
-                <a:cs typeface="Calibri" pitchFamily="34" charset="-120"/>
-              </a:rPr>
-              <a:t>which puts it on this desk. The industry's own conclusion is that attacking waste after the fact has hit diminishing returns; the returns now come from ownership, governance and scope.</a:t>
+                  <a:srgbClr val="1B2430"/>
+                </a:solidFill>
+                <a:latin typeface="Calibri" pitchFamily="34" charset="0"/>
+                <a:ea typeface="Calibri" pitchFamily="34" charset="-122"/>
+                <a:cs typeface="Calibri" pitchFamily="34" charset="-120"/>
+              </a:rPr>
+              <a:t>The review then sees a single number with a single owner — and the model's share becomes a ratio anyone can argue with, rather than the headline.</a:t>
             </a:r>
             <a:endParaRPr lang="en-US" sz="1350" dirty="0"/>
           </a:p>
@@ -2723,1102 +3019,6 @@
 <file path=ppt/slides/slide3.xml><?xml version="1.0" encoding="utf-8"?>
 <p:sld xmlns:a="http://schemas.openxmlformats.org/drawingml/2006/main" xmlns:r="http://schemas.openxmlformats.org/officeDocument/2006/relationships" xmlns:p="http://schemas.openxmlformats.org/presentationml/2006/main">
   <p:cSld name="Slide 3">
-    <p:bg>
-      <p:bgPr>
-        <a:solidFill>
-          <a:srgbClr val="FFFFFF"/>
-        </a:solidFill>
-      </p:bgPr>
-    </p:bg>
-    <p:spTree>
-      <p:nvGrpSpPr>
-        <p:cNvPr id="1" name=""/>
-        <p:cNvGrpSpPr/>
-        <p:nvPr/>
-      </p:nvGrpSpPr>
-      <p:grpSpPr>
-        <a:xfrm>
-          <a:off x="0" y="0"/>
-          <a:ext cx="0" cy="0"/>
-          <a:chOff x="0" y="0"/>
-          <a:chExt cx="0" cy="0"/>
-        </a:xfrm>
-      </p:grpSpPr>
-      <p:sp>
-        <p:nvSpPr>
-          <p:cNvPr id="2" name="Text 0"/>
-          <p:cNvSpPr/>
-          <p:nvPr/>
-        </p:nvSpPr>
-        <p:spPr>
-          <a:xfrm>
-            <a:off x="548640" y="475488"/>
-            <a:ext cx="7315200" cy="256032"/>
-          </a:xfrm>
-          <a:prstGeom prst="rect">
-            <a:avLst/>
-          </a:prstGeom>
-          <a:noFill/>
-          <a:ln/>
-        </p:spPr>
-        <p:txBody>
-          <a:bodyPr wrap="square" lIns="0" tIns="0" rIns="0" bIns="0" rtlCol="0" anchor="ctr"/>
-          <a:lstStyle/>
-          <a:p>
-            <a:pPr indent="0" marL="0">
-              <a:buNone/>
-            </a:pPr>
-            <a:r>
-              <a:rPr lang="en-US" sz="1100" b="1" spc="220" kern="0" dirty="0">
-                <a:solidFill>
-                  <a:srgbClr val="E39B2C"/>
-                </a:solidFill>
-                <a:latin typeface="Calibri" pitchFamily="34" charset="0"/>
-                <a:ea typeface="Calibri" pitchFamily="34" charset="-122"/>
-                <a:cs typeface="Calibri" pitchFamily="34" charset="-120"/>
-              </a:rPr>
-              <a:t>STEP ONE — SEE IT</a:t>
-            </a:r>
-            <a:endParaRPr lang="en-US" sz="1100" dirty="0"/>
-          </a:p>
-        </p:txBody>
-      </p:sp>
-      <p:sp>
-        <p:nvSpPr>
-          <p:cNvPr id="3" name="Text 1"/>
-          <p:cNvSpPr/>
-          <p:nvPr/>
-        </p:nvSpPr>
-        <p:spPr>
-          <a:xfrm>
-            <a:off x="548640" y="768096"/>
-            <a:ext cx="11091672" cy="804672"/>
-          </a:xfrm>
-          <a:prstGeom prst="rect">
-            <a:avLst/>
-          </a:prstGeom>
-          <a:noFill/>
-          <a:ln/>
-        </p:spPr>
-        <p:txBody>
-          <a:bodyPr wrap="square" lIns="0" tIns="0" rIns="0" bIns="0" rtlCol="0" anchor="ctr"/>
-          <a:lstStyle/>
-          <a:p>
-            <a:pPr indent="0" marL="0">
-              <a:buNone/>
-            </a:pPr>
-            <a:r>
-              <a:rPr lang="en-US" sz="3100" b="1" dirty="0">
-                <a:solidFill>
-                  <a:srgbClr val="1B2430"/>
-                </a:solidFill>
-                <a:latin typeface="Cambria" pitchFamily="34" charset="0"/>
-                <a:ea typeface="Cambria" pitchFamily="34" charset="-122"/>
-                <a:cs typeface="Cambria" pitchFamily="34" charset="-120"/>
-              </a:rPr>
-              <a:t>One number per project, with an owner on it</a:t>
-            </a:r>
-            <a:endParaRPr lang="en-US" sz="3100" dirty="0"/>
-          </a:p>
-        </p:txBody>
-      </p:sp>
-      <p:sp>
-        <p:nvSpPr>
-          <p:cNvPr id="4" name="Text 2"/>
-          <p:cNvSpPr/>
-          <p:nvPr/>
-        </p:nvSpPr>
-        <p:spPr>
-          <a:xfrm>
-            <a:off x="548640" y="1536192"/>
-            <a:ext cx="10607040" cy="365760"/>
-          </a:xfrm>
-          <a:prstGeom prst="rect">
-            <a:avLst/>
-          </a:prstGeom>
-          <a:noFill/>
-          <a:ln/>
-        </p:spPr>
-        <p:txBody>
-          <a:bodyPr wrap="square" lIns="0" tIns="0" rIns="0" bIns="0" rtlCol="0" anchor="ctr"/>
-          <a:lstStyle/>
-          <a:p>
-            <a:pPr indent="0" marL="0">
-              <a:buNone/>
-            </a:pPr>
-            <a:r>
-              <a:rPr lang="en-US" sz="1500" dirty="0">
-                <a:solidFill>
-                  <a:srgbClr val="5C6675"/>
-                </a:solidFill>
-                <a:latin typeface="Calibri" pitchFamily="34" charset="0"/>
-                <a:ea typeface="Calibri" pitchFamily="34" charset="-122"/>
-                <a:cs typeface="Calibri" pitchFamily="34" charset="-120"/>
-              </a:rPr>
-              <a:t>Two things have to be true: the cost can be traced to someone, and the project is priced whole.</a:t>
-            </a:r>
-            <a:endParaRPr lang="en-US" sz="1500" dirty="0"/>
-          </a:p>
-        </p:txBody>
-      </p:sp>
-      <p:sp>
-        <p:nvSpPr>
-          <p:cNvPr id="5" name="Shape 3"/>
-          <p:cNvSpPr/>
-          <p:nvPr/>
-        </p:nvSpPr>
-        <p:spPr>
-          <a:xfrm>
-            <a:off x="548640" y="2121408"/>
-            <a:ext cx="5394960" cy="3200400"/>
-          </a:xfrm>
-          <a:prstGeom prst="roundRect">
-            <a:avLst>
-              <a:gd name="adj" fmla="val 2571"/>
-            </a:avLst>
-          </a:prstGeom>
-          <a:solidFill>
-            <a:srgbClr val="F1F3F6"/>
-          </a:solidFill>
-          <a:ln/>
-        </p:spPr>
-      </p:sp>
-      <p:sp>
-        <p:nvSpPr>
-          <p:cNvPr id="6" name="Text 4"/>
-          <p:cNvSpPr/>
-          <p:nvPr/>
-        </p:nvSpPr>
-        <p:spPr>
-          <a:xfrm>
-            <a:off x="859536" y="2286000"/>
-            <a:ext cx="4572000" cy="292608"/>
-          </a:xfrm>
-          <a:prstGeom prst="rect">
-            <a:avLst/>
-          </a:prstGeom>
-          <a:noFill/>
-          <a:ln/>
-        </p:spPr>
-        <p:txBody>
-          <a:bodyPr wrap="square" lIns="0" tIns="0" rIns="0" bIns="0" rtlCol="0" anchor="ctr"/>
-          <a:lstStyle/>
-          <a:p>
-            <a:pPr indent="0" marL="0">
-              <a:buNone/>
-            </a:pPr>
-            <a:r>
-              <a:rPr lang="en-US" sz="1150" b="1" spc="160" kern="0" dirty="0">
-                <a:solidFill>
-                  <a:srgbClr val="5C6675"/>
-                </a:solidFill>
-                <a:latin typeface="Calibri" pitchFamily="34" charset="0"/>
-                <a:ea typeface="Calibri" pitchFamily="34" charset="-122"/>
-                <a:cs typeface="Calibri" pitchFamily="34" charset="-120"/>
-              </a:rPr>
-              <a:t>Trace it to an owner</a:t>
-            </a:r>
-            <a:endParaRPr lang="en-US" sz="1150" dirty="0"/>
-          </a:p>
-        </p:txBody>
-      </p:sp>
-      <p:sp>
-        <p:nvSpPr>
-          <p:cNvPr id="7" name="Text 5"/>
-          <p:cNvSpPr/>
-          <p:nvPr/>
-        </p:nvSpPr>
-        <p:spPr>
-          <a:xfrm>
-            <a:off x="859536" y="2688336"/>
-            <a:ext cx="310896" cy="566928"/>
-          </a:xfrm>
-          <a:prstGeom prst="rect">
-            <a:avLst/>
-          </a:prstGeom>
-          <a:noFill/>
-          <a:ln/>
-        </p:spPr>
-        <p:txBody>
-          <a:bodyPr wrap="square" lIns="0" tIns="0" rIns="0" bIns="0" rtlCol="0" anchor="t"/>
-          <a:lstStyle/>
-          <a:p>
-            <a:pPr indent="0" marL="0">
-              <a:buNone/>
-            </a:pPr>
-            <a:r>
-              <a:rPr lang="en-US" sz="1500" b="1" dirty="0">
-                <a:solidFill>
-                  <a:srgbClr val="E39B2C"/>
-                </a:solidFill>
-                <a:latin typeface="Cambria" pitchFamily="34" charset="0"/>
-                <a:ea typeface="Cambria" pitchFamily="34" charset="-122"/>
-                <a:cs typeface="Cambria" pitchFamily="34" charset="-120"/>
-              </a:rPr>
-              <a:t>1</a:t>
-            </a:r>
-            <a:endParaRPr lang="en-US" sz="1500" dirty="0"/>
-          </a:p>
-        </p:txBody>
-      </p:sp>
-      <p:sp>
-        <p:nvSpPr>
-          <p:cNvPr id="8" name="Text 6"/>
-          <p:cNvSpPr/>
-          <p:nvPr/>
-        </p:nvSpPr>
-        <p:spPr>
-          <a:xfrm>
-            <a:off x="1225296" y="2688336"/>
-            <a:ext cx="4407408" cy="621792"/>
-          </a:xfrm>
-          <a:prstGeom prst="rect">
-            <a:avLst/>
-          </a:prstGeom>
-          <a:noFill/>
-          <a:ln/>
-        </p:spPr>
-        <p:txBody>
-          <a:bodyPr wrap="square" lIns="0" tIns="0" rIns="0" bIns="0" rtlCol="0" anchor="t"/>
-          <a:lstStyle/>
-          <a:p>
-            <a:pPr indent="0" marL="0">
-              <a:lnSpc>
-                <a:spcPts val="1600"/>
-              </a:lnSpc>
-              <a:buNone/>
-            </a:pPr>
-            <a:r>
-              <a:rPr lang="en-US" sz="1250" b="1" dirty="0">
-                <a:solidFill>
-                  <a:srgbClr val="1B2430"/>
-                </a:solidFill>
-                <a:latin typeface="Calibri" pitchFamily="34" charset="0"/>
-                <a:ea typeface="Calibri" pitchFamily="34" charset="-122"/>
-                <a:cs typeface="Calibri" pitchFamily="34" charset="-120"/>
-              </a:rPr>
-              <a:t>Tag at creation</a:t>
-            </a:r>
-            <a:endParaRPr lang="en-US" sz="1250" dirty="0"/>
-          </a:p>
-          <a:p>
-            <a:pPr indent="0" marL="0">
-              <a:lnSpc>
-                <a:spcPts val="1600"/>
-              </a:lnSpc>
-              <a:buNone/>
-            </a:pPr>
-            <a:r>
-              <a:rPr lang="en-US" sz="1250" dirty="0">
-                <a:solidFill>
-                  <a:srgbClr val="5C6675"/>
-                </a:solidFill>
-                <a:latin typeface="Calibri" pitchFamily="34" charset="0"/>
-                <a:ea typeface="Calibri" pitchFamily="34" charset="-122"/>
-                <a:cs typeface="Calibri" pitchFamily="34" charset="-120"/>
-              </a:rPr>
-              <a:t>Five tags, enforced by policy. Untagged means undeployed.</a:t>
-            </a:r>
-            <a:endParaRPr lang="en-US" sz="1250" dirty="0"/>
-          </a:p>
-        </p:txBody>
-      </p:sp>
-      <p:sp>
-        <p:nvSpPr>
-          <p:cNvPr id="9" name="Text 7"/>
-          <p:cNvSpPr/>
-          <p:nvPr/>
-        </p:nvSpPr>
-        <p:spPr>
-          <a:xfrm>
-            <a:off x="859536" y="3328416"/>
-            <a:ext cx="310896" cy="566928"/>
-          </a:xfrm>
-          <a:prstGeom prst="rect">
-            <a:avLst/>
-          </a:prstGeom>
-          <a:noFill/>
-          <a:ln/>
-        </p:spPr>
-        <p:txBody>
-          <a:bodyPr wrap="square" lIns="0" tIns="0" rIns="0" bIns="0" rtlCol="0" anchor="t"/>
-          <a:lstStyle/>
-          <a:p>
-            <a:pPr indent="0" marL="0">
-              <a:buNone/>
-            </a:pPr>
-            <a:r>
-              <a:rPr lang="en-US" sz="1500" b="1" dirty="0">
-                <a:solidFill>
-                  <a:srgbClr val="E39B2C"/>
-                </a:solidFill>
-                <a:latin typeface="Cambria" pitchFamily="34" charset="0"/>
-                <a:ea typeface="Cambria" pitchFamily="34" charset="-122"/>
-                <a:cs typeface="Cambria" pitchFamily="34" charset="-120"/>
-              </a:rPr>
-              <a:t>2</a:t>
-            </a:r>
-            <a:endParaRPr lang="en-US" sz="1500" dirty="0"/>
-          </a:p>
-        </p:txBody>
-      </p:sp>
-      <p:sp>
-        <p:nvSpPr>
-          <p:cNvPr id="10" name="Text 8"/>
-          <p:cNvSpPr/>
-          <p:nvPr/>
-        </p:nvSpPr>
-        <p:spPr>
-          <a:xfrm>
-            <a:off x="1225296" y="3328416"/>
-            <a:ext cx="4407408" cy="621792"/>
-          </a:xfrm>
-          <a:prstGeom prst="rect">
-            <a:avLst/>
-          </a:prstGeom>
-          <a:noFill/>
-          <a:ln/>
-        </p:spPr>
-        <p:txBody>
-          <a:bodyPr wrap="square" lIns="0" tIns="0" rIns="0" bIns="0" rtlCol="0" anchor="t"/>
-          <a:lstStyle/>
-          <a:p>
-            <a:pPr indent="0" marL="0">
-              <a:lnSpc>
-                <a:spcPts val="1600"/>
-              </a:lnSpc>
-              <a:buNone/>
-            </a:pPr>
-            <a:r>
-              <a:rPr lang="en-US" sz="1250" b="1" dirty="0">
-                <a:solidFill>
-                  <a:srgbClr val="1B2430"/>
-                </a:solidFill>
-                <a:latin typeface="Calibri" pitchFamily="34" charset="0"/>
-                <a:ea typeface="Calibri" pitchFamily="34" charset="-122"/>
-                <a:cs typeface="Calibri" pitchFamily="34" charset="-120"/>
-              </a:rPr>
-              <a:t>Allocate the spend</a:t>
-            </a:r>
-            <a:endParaRPr lang="en-US" sz="1250" dirty="0"/>
-          </a:p>
-          <a:p>
-            <a:pPr indent="0" marL="0">
-              <a:lnSpc>
-                <a:spcPts val="1600"/>
-              </a:lnSpc>
-              <a:buNone/>
-            </a:pPr>
-            <a:r>
-              <a:rPr lang="en-US" sz="1250" dirty="0">
-                <a:solidFill>
-                  <a:srgbClr val="5C6675"/>
-                </a:solidFill>
-                <a:latin typeface="Calibri" pitchFamily="34" charset="0"/>
-                <a:ea typeface="Calibri" pitchFamily="34" charset="-122"/>
-                <a:cs typeface="Calibri" pitchFamily="34" charset="-120"/>
-              </a:rPr>
-              <a:t>Target under 5% unallocated, reported weekly.</a:t>
-            </a:r>
-            <a:endParaRPr lang="en-US" sz="1250" dirty="0"/>
-          </a:p>
-        </p:txBody>
-      </p:sp>
-      <p:sp>
-        <p:nvSpPr>
-          <p:cNvPr id="11" name="Text 9"/>
-          <p:cNvSpPr/>
-          <p:nvPr/>
-        </p:nvSpPr>
-        <p:spPr>
-          <a:xfrm>
-            <a:off x="859536" y="3968496"/>
-            <a:ext cx="310896" cy="566928"/>
-          </a:xfrm>
-          <a:prstGeom prst="rect">
-            <a:avLst/>
-          </a:prstGeom>
-          <a:noFill/>
-          <a:ln/>
-        </p:spPr>
-        <p:txBody>
-          <a:bodyPr wrap="square" lIns="0" tIns="0" rIns="0" bIns="0" rtlCol="0" anchor="t"/>
-          <a:lstStyle/>
-          <a:p>
-            <a:pPr indent="0" marL="0">
-              <a:buNone/>
-            </a:pPr>
-            <a:r>
-              <a:rPr lang="en-US" sz="1500" b="1" dirty="0">
-                <a:solidFill>
-                  <a:srgbClr val="E39B2C"/>
-                </a:solidFill>
-                <a:latin typeface="Cambria" pitchFamily="34" charset="0"/>
-                <a:ea typeface="Cambria" pitchFamily="34" charset="-122"/>
-                <a:cs typeface="Cambria" pitchFamily="34" charset="-120"/>
-              </a:rPr>
-              <a:t>3</a:t>
-            </a:r>
-            <a:endParaRPr lang="en-US" sz="1500" dirty="0"/>
-          </a:p>
-        </p:txBody>
-      </p:sp>
-      <p:sp>
-        <p:nvSpPr>
-          <p:cNvPr id="12" name="Text 10"/>
-          <p:cNvSpPr/>
-          <p:nvPr/>
-        </p:nvSpPr>
-        <p:spPr>
-          <a:xfrm>
-            <a:off x="1225296" y="3968496"/>
-            <a:ext cx="4407408" cy="621792"/>
-          </a:xfrm>
-          <a:prstGeom prst="rect">
-            <a:avLst/>
-          </a:prstGeom>
-          <a:noFill/>
-          <a:ln/>
-        </p:spPr>
-        <p:txBody>
-          <a:bodyPr wrap="square" lIns="0" tIns="0" rIns="0" bIns="0" rtlCol="0" anchor="t"/>
-          <a:lstStyle/>
-          <a:p>
-            <a:pPr indent="0" marL="0">
-              <a:lnSpc>
-                <a:spcPts val="1600"/>
-              </a:lnSpc>
-              <a:buNone/>
-            </a:pPr>
-            <a:r>
-              <a:rPr lang="en-US" sz="1250" b="1" dirty="0">
-                <a:solidFill>
-                  <a:srgbClr val="1B2430"/>
-                </a:solidFill>
-                <a:latin typeface="Calibri" pitchFamily="34" charset="0"/>
-                <a:ea typeface="Calibri" pitchFamily="34" charset="-122"/>
-                <a:cs typeface="Calibri" pitchFamily="34" charset="-120"/>
-              </a:rPr>
-              <a:t>Show teams their own numbers</a:t>
-            </a:r>
-            <a:endParaRPr lang="en-US" sz="1250" dirty="0"/>
-          </a:p>
-          <a:p>
-            <a:pPr indent="0" marL="0">
-              <a:lnSpc>
-                <a:spcPts val="1600"/>
-              </a:lnSpc>
-              <a:buNone/>
-            </a:pPr>
-            <a:r>
-              <a:rPr lang="en-US" sz="1250" dirty="0">
-                <a:solidFill>
-                  <a:srgbClr val="5C6675"/>
-                </a:solidFill>
-                <a:latin typeface="Calibri" pitchFamily="34" charset="0"/>
-                <a:ea typeface="Calibri" pitchFamily="34" charset="-122"/>
-                <a:cs typeface="Calibri" pitchFamily="34" charset="-120"/>
-              </a:rPr>
-              <a:t>Four to six weeks before anything is charged.</a:t>
-            </a:r>
-            <a:endParaRPr lang="en-US" sz="1250" dirty="0"/>
-          </a:p>
-        </p:txBody>
-      </p:sp>
-      <p:sp>
-        <p:nvSpPr>
-          <p:cNvPr id="13" name="Text 11"/>
-          <p:cNvSpPr/>
-          <p:nvPr/>
-        </p:nvSpPr>
-        <p:spPr>
-          <a:xfrm>
-            <a:off x="859536" y="4608576"/>
-            <a:ext cx="310896" cy="566928"/>
-          </a:xfrm>
-          <a:prstGeom prst="rect">
-            <a:avLst/>
-          </a:prstGeom>
-          <a:noFill/>
-          <a:ln/>
-        </p:spPr>
-        <p:txBody>
-          <a:bodyPr wrap="square" lIns="0" tIns="0" rIns="0" bIns="0" rtlCol="0" anchor="t"/>
-          <a:lstStyle/>
-          <a:p>
-            <a:pPr indent="0" marL="0">
-              <a:buNone/>
-            </a:pPr>
-            <a:r>
-              <a:rPr lang="en-US" sz="1500" b="1" dirty="0">
-                <a:solidFill>
-                  <a:srgbClr val="E39B2C"/>
-                </a:solidFill>
-                <a:latin typeface="Cambria" pitchFamily="34" charset="0"/>
-                <a:ea typeface="Cambria" pitchFamily="34" charset="-122"/>
-                <a:cs typeface="Cambria" pitchFamily="34" charset="-120"/>
-              </a:rPr>
-              <a:t>4</a:t>
-            </a:r>
-            <a:endParaRPr lang="en-US" sz="1500" dirty="0"/>
-          </a:p>
-        </p:txBody>
-      </p:sp>
-      <p:sp>
-        <p:nvSpPr>
-          <p:cNvPr id="14" name="Text 12"/>
-          <p:cNvSpPr/>
-          <p:nvPr/>
-        </p:nvSpPr>
-        <p:spPr>
-          <a:xfrm>
-            <a:off x="1225296" y="4608576"/>
-            <a:ext cx="4407408" cy="621792"/>
-          </a:xfrm>
-          <a:prstGeom prst="rect">
-            <a:avLst/>
-          </a:prstGeom>
-          <a:noFill/>
-          <a:ln/>
-        </p:spPr>
-        <p:txBody>
-          <a:bodyPr wrap="square" lIns="0" tIns="0" rIns="0" bIns="0" rtlCol="0" anchor="t"/>
-          <a:lstStyle/>
-          <a:p>
-            <a:pPr indent="0" marL="0">
-              <a:lnSpc>
-                <a:spcPts val="1600"/>
-              </a:lnSpc>
-              <a:buNone/>
-            </a:pPr>
-            <a:r>
-              <a:rPr lang="en-US" sz="1250" b="1" dirty="0">
-                <a:solidFill>
-                  <a:srgbClr val="1B2430"/>
-                </a:solidFill>
-                <a:latin typeface="Calibri" pitchFamily="34" charset="0"/>
-                <a:ea typeface="Calibri" pitchFamily="34" charset="-122"/>
-                <a:cs typeface="Calibri" pitchFamily="34" charset="-120"/>
-              </a:rPr>
-              <a:t>Divide by the unit</a:t>
-            </a:r>
-            <a:endParaRPr lang="en-US" sz="1250" dirty="0"/>
-          </a:p>
-          <a:p>
-            <a:pPr indent="0" marL="0">
-              <a:lnSpc>
-                <a:spcPts val="1600"/>
-              </a:lnSpc>
-              <a:buNone/>
-            </a:pPr>
-            <a:r>
-              <a:rPr lang="en-US" sz="1250" dirty="0">
-                <a:solidFill>
-                  <a:srgbClr val="5C6675"/>
-                </a:solidFill>
-                <a:latin typeface="Calibri" pitchFamily="34" charset="0"/>
-                <a:ea typeface="Calibri" pitchFamily="34" charset="-122"/>
-                <a:cs typeface="Calibri" pitchFamily="34" charset="-120"/>
-              </a:rPr>
-              <a:t>Cost per customer, per order, per conversation.</a:t>
-            </a:r>
-            <a:endParaRPr lang="en-US" sz="1250" dirty="0"/>
-          </a:p>
-        </p:txBody>
-      </p:sp>
-      <p:sp>
-        <p:nvSpPr>
-          <p:cNvPr id="15" name="Shape 13"/>
-          <p:cNvSpPr/>
-          <p:nvPr/>
-        </p:nvSpPr>
-        <p:spPr>
-          <a:xfrm>
-            <a:off x="6245352" y="2121408"/>
-            <a:ext cx="5394960" cy="3200400"/>
-          </a:xfrm>
-          <a:prstGeom prst="roundRect">
-            <a:avLst>
-              <a:gd name="adj" fmla="val 2571"/>
-            </a:avLst>
-          </a:prstGeom>
-          <a:solidFill>
-            <a:srgbClr val="1F2936"/>
-          </a:solidFill>
-          <a:ln/>
-          <a:effectLst>
-            <a:outerShdw sx="100000" sy="100000" kx="0" ky="0" algn="bl" rotWithShape="0" blurRad="127000" dist="25400" dir="5400000">
-              <a:srgbClr val="8C99A8">
-                <a:alpha val="16000"/>
-              </a:srgbClr>
-            </a:outerShdw>
-          </a:effectLst>
-        </p:spPr>
-      </p:sp>
-      <p:sp>
-        <p:nvSpPr>
-          <p:cNvPr id="16" name="Text 14"/>
-          <p:cNvSpPr/>
-          <p:nvPr/>
-        </p:nvSpPr>
-        <p:spPr>
-          <a:xfrm>
-            <a:off x="6556248" y="2286000"/>
-            <a:ext cx="4572000" cy="292608"/>
-          </a:xfrm>
-          <a:prstGeom prst="rect">
-            <a:avLst/>
-          </a:prstGeom>
-          <a:noFill/>
-          <a:ln/>
-        </p:spPr>
-        <p:txBody>
-          <a:bodyPr wrap="square" lIns="0" tIns="0" rIns="0" bIns="0" rtlCol="0" anchor="ctr"/>
-          <a:lstStyle/>
-          <a:p>
-            <a:pPr indent="0" marL="0">
-              <a:buNone/>
-            </a:pPr>
-            <a:r>
-              <a:rPr lang="en-US" sz="1150" b="1" spc="160" kern="0" dirty="0">
-                <a:solidFill>
-                  <a:srgbClr val="E39B2C"/>
-                </a:solidFill>
-                <a:latin typeface="Calibri" pitchFamily="34" charset="0"/>
-                <a:ea typeface="Calibri" pitchFamily="34" charset="-122"/>
-                <a:cs typeface="Calibri" pitchFamily="34" charset="-120"/>
-              </a:rPr>
-              <a:t>Price the project whole</a:t>
-            </a:r>
-            <a:endParaRPr lang="en-US" sz="1150" dirty="0"/>
-          </a:p>
-        </p:txBody>
-      </p:sp>
-      <p:sp>
-        <p:nvSpPr>
-          <p:cNvPr id="17" name="Text 15"/>
-          <p:cNvSpPr/>
-          <p:nvPr/>
-        </p:nvSpPr>
-        <p:spPr>
-          <a:xfrm>
-            <a:off x="6556248" y="2615184"/>
-            <a:ext cx="4773168" cy="457200"/>
-          </a:xfrm>
-          <a:prstGeom prst="rect">
-            <a:avLst/>
-          </a:prstGeom>
-          <a:noFill/>
-          <a:ln/>
-        </p:spPr>
-        <p:txBody>
-          <a:bodyPr wrap="square" lIns="0" tIns="0" rIns="0" bIns="0" rtlCol="0" anchor="t"/>
-          <a:lstStyle/>
-          <a:p>
-            <a:pPr indent="0" marL="0">
-              <a:lnSpc>
-                <a:spcPts val="1700"/>
-              </a:lnSpc>
-              <a:buNone/>
-            </a:pPr>
-            <a:r>
-              <a:rPr lang="en-US" sz="1250" dirty="0">
-                <a:solidFill>
-                  <a:srgbClr val="9EABBA"/>
-                </a:solidFill>
-                <a:latin typeface="Calibri" pitchFamily="34" charset="0"/>
-                <a:ea typeface="Calibri" pitchFamily="34" charset="-122"/>
-                <a:cs typeface="Calibri" pitchFamily="34" charset="-120"/>
-              </a:rPr>
-              <a:t>An AI feature is quoted at its token cost. It runs on a stack that bills every month regardless.</a:t>
-            </a:r>
-            <a:endParaRPr lang="en-US" sz="1250" dirty="0"/>
-          </a:p>
-        </p:txBody>
-      </p:sp>
-      <p:sp>
-        <p:nvSpPr>
-          <p:cNvPr id="18" name="Shape 16"/>
-          <p:cNvSpPr/>
-          <p:nvPr/>
-        </p:nvSpPr>
-        <p:spPr>
-          <a:xfrm>
-            <a:off x="6556248" y="3291840"/>
-            <a:ext cx="82296" cy="274320"/>
-          </a:xfrm>
-          <a:prstGeom prst="roundRect">
-            <a:avLst>
-              <a:gd name="adj" fmla="val 44444"/>
-            </a:avLst>
-          </a:prstGeom>
-          <a:solidFill>
-            <a:srgbClr val="E39B2C"/>
-          </a:solidFill>
-          <a:ln/>
-        </p:spPr>
-      </p:sp>
-      <p:sp>
-        <p:nvSpPr>
-          <p:cNvPr id="19" name="Text 17"/>
-          <p:cNvSpPr/>
-          <p:nvPr/>
-        </p:nvSpPr>
-        <p:spPr>
-          <a:xfrm>
-            <a:off x="6766560" y="3200400"/>
-            <a:ext cx="4572000" cy="512064"/>
-          </a:xfrm>
-          <a:prstGeom prst="rect">
-            <a:avLst/>
-          </a:prstGeom>
-          <a:noFill/>
-          <a:ln/>
-        </p:spPr>
-        <p:txBody>
-          <a:bodyPr wrap="square" lIns="0" tIns="0" rIns="0" bIns="0" rtlCol="0" anchor="t"/>
-          <a:lstStyle/>
-          <a:p>
-            <a:pPr indent="0" marL="0">
-              <a:lnSpc>
-                <a:spcPts val="1600"/>
-              </a:lnSpc>
-              <a:buNone/>
-            </a:pPr>
-            <a:r>
-              <a:rPr lang="en-US" sz="1250" b="1" dirty="0">
-                <a:solidFill>
-                  <a:srgbClr val="E39B2C"/>
-                </a:solidFill>
-                <a:latin typeface="Calibri" pitchFamily="34" charset="0"/>
-                <a:ea typeface="Calibri" pitchFamily="34" charset="-122"/>
-                <a:cs typeface="Calibri" pitchFamily="34" charset="-120"/>
-              </a:rPr>
-              <a:t>Model / tokens</a:t>
-            </a:r>
-            <a:endParaRPr lang="en-US" sz="1250" dirty="0"/>
-          </a:p>
-          <a:p>
-            <a:pPr indent="0" marL="0">
-              <a:lnSpc>
-                <a:spcPts val="1600"/>
-              </a:lnSpc>
-              <a:buNone/>
-            </a:pPr>
-            <a:r>
-              <a:rPr lang="en-US" sz="1250" dirty="0">
-                <a:solidFill>
-                  <a:srgbClr val="9EABBA"/>
-                </a:solidFill>
-                <a:latin typeface="Calibri" pitchFamily="34" charset="0"/>
-                <a:ea typeface="Calibri" pitchFamily="34" charset="-122"/>
-                <a:cs typeface="Calibri" pitchFamily="34" charset="-120"/>
-              </a:rPr>
-              <a:t>the line everyone quotes</a:t>
-            </a:r>
-            <a:endParaRPr lang="en-US" sz="1250" dirty="0"/>
-          </a:p>
-        </p:txBody>
-      </p:sp>
-      <p:sp>
-        <p:nvSpPr>
-          <p:cNvPr id="20" name="Shape 18"/>
-          <p:cNvSpPr/>
-          <p:nvPr/>
-        </p:nvSpPr>
-        <p:spPr>
-          <a:xfrm>
-            <a:off x="6556248" y="3858768"/>
-            <a:ext cx="82296" cy="274320"/>
-          </a:xfrm>
-          <a:prstGeom prst="roundRect">
-            <a:avLst>
-              <a:gd name="adj" fmla="val 44444"/>
-            </a:avLst>
-          </a:prstGeom>
-          <a:solidFill>
-            <a:srgbClr val="8C9AAC"/>
-          </a:solidFill>
-          <a:ln/>
-        </p:spPr>
-      </p:sp>
-      <p:sp>
-        <p:nvSpPr>
-          <p:cNvPr id="21" name="Text 19"/>
-          <p:cNvSpPr/>
-          <p:nvPr/>
-        </p:nvSpPr>
-        <p:spPr>
-          <a:xfrm>
-            <a:off x="6766560" y="3767328"/>
-            <a:ext cx="4572000" cy="512064"/>
-          </a:xfrm>
-          <a:prstGeom prst="rect">
-            <a:avLst/>
-          </a:prstGeom>
-          <a:noFill/>
-          <a:ln/>
-        </p:spPr>
-        <p:txBody>
-          <a:bodyPr wrap="square" lIns="0" tIns="0" rIns="0" bIns="0" rtlCol="0" anchor="t"/>
-          <a:lstStyle/>
-          <a:p>
-            <a:pPr indent="0" marL="0">
-              <a:lnSpc>
-                <a:spcPts val="1600"/>
-              </a:lnSpc>
-              <a:buNone/>
-            </a:pPr>
-            <a:r>
-              <a:rPr lang="en-US" sz="1250" b="1" dirty="0">
-                <a:solidFill>
-                  <a:srgbClr val="FFFFFF"/>
-                </a:solidFill>
-                <a:latin typeface="Calibri" pitchFamily="34" charset="0"/>
-                <a:ea typeface="Calibri" pitchFamily="34" charset="-122"/>
-                <a:cs typeface="Calibri" pitchFamily="34" charset="-120"/>
-              </a:rPr>
-              <a:t>Compute, databases, cache</a:t>
-            </a:r>
-            <a:endParaRPr lang="en-US" sz="1250" dirty="0"/>
-          </a:p>
-          <a:p>
-            <a:pPr indent="0" marL="0">
-              <a:lnSpc>
-                <a:spcPts val="1600"/>
-              </a:lnSpc>
-              <a:buNone/>
-            </a:pPr>
-            <a:r>
-              <a:rPr lang="en-US" sz="1250" dirty="0">
-                <a:solidFill>
-                  <a:srgbClr val="9EABBA"/>
-                </a:solidFill>
-                <a:latin typeface="Calibri" pitchFamily="34" charset="0"/>
-                <a:ea typeface="Calibri" pitchFamily="34" charset="-122"/>
-                <a:cs typeface="Calibri" pitchFamily="34" charset="-120"/>
-              </a:rPr>
-              <a:t>app services, SQL, Redis, queues</a:t>
-            </a:r>
-            <a:endParaRPr lang="en-US" sz="1250" dirty="0"/>
-          </a:p>
-        </p:txBody>
-      </p:sp>
-      <p:sp>
-        <p:nvSpPr>
-          <p:cNvPr id="22" name="Shape 20"/>
-          <p:cNvSpPr/>
-          <p:nvPr/>
-        </p:nvSpPr>
-        <p:spPr>
-          <a:xfrm>
-            <a:off x="6556248" y="4425696"/>
-            <a:ext cx="82296" cy="274320"/>
-          </a:xfrm>
-          <a:prstGeom prst="roundRect">
-            <a:avLst>
-              <a:gd name="adj" fmla="val 44444"/>
-            </a:avLst>
-          </a:prstGeom>
-          <a:solidFill>
-            <a:srgbClr val="8C9AAC"/>
-          </a:solidFill>
-          <a:ln/>
-        </p:spPr>
-      </p:sp>
-      <p:sp>
-        <p:nvSpPr>
-          <p:cNvPr id="23" name="Text 21"/>
-          <p:cNvSpPr/>
-          <p:nvPr/>
-        </p:nvSpPr>
-        <p:spPr>
-          <a:xfrm>
-            <a:off x="6766560" y="4334256"/>
-            <a:ext cx="4572000" cy="512064"/>
-          </a:xfrm>
-          <a:prstGeom prst="rect">
-            <a:avLst/>
-          </a:prstGeom>
-          <a:noFill/>
-          <a:ln/>
-        </p:spPr>
-        <p:txBody>
-          <a:bodyPr wrap="square" lIns="0" tIns="0" rIns="0" bIns="0" rtlCol="0" anchor="t"/>
-          <a:lstStyle/>
-          <a:p>
-            <a:pPr indent="0" marL="0">
-              <a:lnSpc>
-                <a:spcPts val="1600"/>
-              </a:lnSpc>
-              <a:buNone/>
-            </a:pPr>
-            <a:r>
-              <a:rPr lang="en-US" sz="1250" b="1" dirty="0">
-                <a:solidFill>
-                  <a:srgbClr val="FFFFFF"/>
-                </a:solidFill>
-                <a:latin typeface="Calibri" pitchFamily="34" charset="0"/>
-                <a:ea typeface="Calibri" pitchFamily="34" charset="-122"/>
-                <a:cs typeface="Calibri" pitchFamily="34" charset="-120"/>
-              </a:rPr>
-              <a:t>Storage, network, observability</a:t>
-            </a:r>
-            <a:endParaRPr lang="en-US" sz="1250" dirty="0"/>
-          </a:p>
-          <a:p>
-            <a:pPr indent="0" marL="0">
-              <a:lnSpc>
-                <a:spcPts val="1600"/>
-              </a:lnSpc>
-              <a:buNone/>
-            </a:pPr>
-            <a:r>
-              <a:rPr lang="en-US" sz="1250" dirty="0">
-                <a:solidFill>
-                  <a:srgbClr val="9EABBA"/>
-                </a:solidFill>
-                <a:latin typeface="Calibri" pitchFamily="34" charset="0"/>
-                <a:ea typeface="Calibri" pitchFamily="34" charset="-122"/>
-                <a:cs typeface="Calibri" pitchFamily="34" charset="-120"/>
-              </a:rPr>
-              <a:t>backups, egress, log ingestion</a:t>
-            </a:r>
-            <a:endParaRPr lang="en-US" sz="1250" dirty="0"/>
-          </a:p>
-        </p:txBody>
-      </p:sp>
-      <p:sp>
-        <p:nvSpPr>
-          <p:cNvPr id="24" name="Text 22"/>
-          <p:cNvSpPr/>
-          <p:nvPr/>
-        </p:nvSpPr>
-        <p:spPr>
-          <a:xfrm>
-            <a:off x="6556248" y="4901184"/>
-            <a:ext cx="4572000" cy="274320"/>
-          </a:xfrm>
-          <a:prstGeom prst="rect">
-            <a:avLst/>
-          </a:prstGeom>
-          <a:noFill/>
-          <a:ln/>
-        </p:spPr>
-        <p:txBody>
-          <a:bodyPr wrap="square" lIns="0" tIns="0" rIns="0" bIns="0" rtlCol="0" anchor="t"/>
-          <a:lstStyle/>
-          <a:p>
-            <a:pPr indent="0" marL="0">
-              <a:buNone/>
-            </a:pPr>
-            <a:r>
-              <a:rPr lang="en-US" sz="1150" i="1" dirty="0">
-                <a:solidFill>
-                  <a:srgbClr val="9EABBA"/>
-                </a:solidFill>
-                <a:latin typeface="Calibri" pitchFamily="34" charset="0"/>
-                <a:ea typeface="Calibri" pitchFamily="34" charset="-122"/>
-                <a:cs typeface="Calibri" pitchFamily="34" charset="-120"/>
-              </a:rPr>
-              <a:t>Every layer bills whether or not the model is called.</a:t>
-            </a:r>
-            <a:endParaRPr lang="en-US" sz="1150" dirty="0"/>
-          </a:p>
-        </p:txBody>
-      </p:sp>
-      <p:sp>
-        <p:nvSpPr>
-          <p:cNvPr id="25" name="Shape 23"/>
-          <p:cNvSpPr/>
-          <p:nvPr/>
-        </p:nvSpPr>
-        <p:spPr>
-          <a:xfrm>
-            <a:off x="548640" y="5504688"/>
-            <a:ext cx="11091672" cy="914400"/>
-          </a:xfrm>
-          <a:prstGeom prst="roundRect">
-            <a:avLst>
-              <a:gd name="adj" fmla="val 9000"/>
-            </a:avLst>
-          </a:prstGeom>
-          <a:solidFill>
-            <a:srgbClr val="DDEDE9"/>
-          </a:solidFill>
-          <a:ln/>
-        </p:spPr>
-      </p:sp>
-      <p:sp>
-        <p:nvSpPr>
-          <p:cNvPr id="26" name="Text 24"/>
-          <p:cNvSpPr/>
-          <p:nvPr/>
-        </p:nvSpPr>
-        <p:spPr>
-          <a:xfrm>
-            <a:off x="877824" y="5504688"/>
-            <a:ext cx="10424160" cy="914400"/>
-          </a:xfrm>
-          <a:prstGeom prst="rect">
-            <a:avLst/>
-          </a:prstGeom>
-          <a:noFill/>
-          <a:ln/>
-        </p:spPr>
-        <p:txBody>
-          <a:bodyPr wrap="square" lIns="0" tIns="0" rIns="0" bIns="0" rtlCol="0" anchor="ctr"/>
-          <a:lstStyle/>
-          <a:p>
-            <a:pPr indent="0" marL="0">
-              <a:lnSpc>
-                <a:spcPts val="1900"/>
-              </a:lnSpc>
-              <a:buNone/>
-            </a:pPr>
-            <a:r>
-              <a:rPr lang="en-US" sz="1350" b="1" dirty="0">
-                <a:solidFill>
-                  <a:srgbClr val="1B2430"/>
-                </a:solidFill>
-                <a:latin typeface="Calibri" pitchFamily="34" charset="0"/>
-                <a:ea typeface="Calibri" pitchFamily="34" charset="-122"/>
-                <a:cs typeface="Calibri" pitchFamily="34" charset="-120"/>
-              </a:rPr>
-              <a:t>One ApplicationID across every resource a project touches. </a:t>
-            </a:r>
-            <a:pPr indent="0" marL="0">
-              <a:lnSpc>
-                <a:spcPts val="1900"/>
-              </a:lnSpc>
-              <a:buNone/>
-            </a:pPr>
-            <a:r>
-              <a:rPr lang="en-US" sz="1350" dirty="0">
-                <a:solidFill>
-                  <a:srgbClr val="1B2430"/>
-                </a:solidFill>
-                <a:latin typeface="Calibri" pitchFamily="34" charset="0"/>
-                <a:ea typeface="Calibri" pitchFamily="34" charset="-122"/>
-                <a:cs typeface="Calibri" pitchFamily="34" charset="-120"/>
-              </a:rPr>
-              <a:t>The review then sees a single number with a single owner — and the model's share becomes a ratio anyone can argue with, rather than the headline.</a:t>
-            </a:r>
-            <a:endParaRPr lang="en-US" sz="1350" dirty="0"/>
-          </a:p>
-        </p:txBody>
-      </p:sp>
-    </p:spTree>
-  </p:cSld>
-  <p:clrMapOvr>
-    <a:masterClrMapping/>
-  </p:clrMapOvr>
-</p:sld>
-</file>
-
-<file path=ppt/slides/slide4.xml><?xml version="1.0" encoding="utf-8"?>
-<p:sld xmlns:a="http://schemas.openxmlformats.org/drawingml/2006/main" xmlns:r="http://schemas.openxmlformats.org/officeDocument/2006/relationships" xmlns:p="http://schemas.openxmlformats.org/presentationml/2006/main">
-  <p:cSld name="Slide 4">
     <p:bg>
       <p:bgPr>
         <a:solidFill>
@@ -4702,9 +3902,9 @@
 </p:sld>
 </file>
 
-<file path=ppt/slides/slide5.xml><?xml version="1.0" encoding="utf-8"?>
+<file path=ppt/slides/slide4.xml><?xml version="1.0" encoding="utf-8"?>
 <p:sld xmlns:a="http://schemas.openxmlformats.org/drawingml/2006/main" xmlns:r="http://schemas.openxmlformats.org/officeDocument/2006/relationships" xmlns:p="http://schemas.openxmlformats.org/presentationml/2006/main">
-  <p:cSld name="Slide 5">
+  <p:cSld name="Slide 4">
     <p:bg>
       <p:bgPr>
         <a:solidFill>

</xml_diff>

<commit_message>
Remove the ask slide from the vision deck: 4 slides down to 3
The closing "ask" slide (90-day plan, KPI panel, two decisions) is cut
per request. The deck now ends on "control it" and carries no dedicated
closing/decisions slide - present finops-cio-brief.pptx alongside it
when a formal ask slide is wanted.

- build-vision-deck.js: drop slideAsk, renumber section comments
- notes-vision.js: drop the "ask" note key, fix vision's cross-references
  (measured is slide 2, limited is slide 3)
- Rebuilt finops-vision.pptx/.pdf (3 slides, validated, notes on all slides)
- Regenerated speaker-notes-vision.md
- README.md: vision deck section now documents 3 slides and the missing
  close
</commit_message>
<xml_diff>
--- a/presentations/finops-vision.pptx
+++ b/presentations/finops-vision.pptx
@@ -8,10 +8,9 @@
     <p:sldId id="256" r:id="rId2"/>
     <p:sldId id="257" r:id="rId3"/>
     <p:sldId id="258" r:id="rId4"/>
-    <p:sldId id="259" r:id="rId5"/>
   </p:sldIdLst>
   <p:notesMasterIdLst>
-    <p:notesMasterId r:id="rId6"/>
+    <p:notesMasterId r:id="rId5"/>
   </p:notesMasterIdLst>
   <p:sldSz cx="12192000" cy="6858000"/>
   <p:notesSz cx="6858000" cy="12192000"/>
@@ -505,7 +504,7 @@
           <a:p>
             <a:r>
               <a:rPr lang="en-US" dirty="0"/>
-              <a:t>Open with the sentence on the slide and stop — let it land before explaining it. Every project has a name, an owner, a number and a limit is the whole vision; everything after this slide is how we get there. Say plainly that this is not a cost-cutting pitch. Cloud and AI are the one large spending line where commitments are made daily, by engineers, with no approval step in between — everywhere else in the budget that would be called a control gap, and closing it is the ask. The four words at the bottom are the structure for the rest of the deck: named and owned are slide 2, measured is slides 2 and 4, limited is slide 3. Naming them here means nothing later needs re-introducing.</a:t>
+              <a:t>Open with the sentence on the slide and stop — let it land before explaining it. Every project has a name, an owner, a number and a limit is the whole vision; everything after this slide is how we get there. Say plainly that this is not a cost-cutting pitch. Cloud and AI are the one large spending line where commitments are made daily, by engineers, with no approval step in between — everywhere else in the budget that would be called a control gap, and closing it is the ask. The four words at the bottom are the structure for the rest of the deck: named and owned are slide 2, measured is slide 2, limited is slide 3. Naming them here means nothing later needs re-introducing.</a:t>
             </a:r>
             <a:endParaRPr lang="en-US" dirty="0"/>
           </a:p>
@@ -705,94 +704,6 @@
             <a:fld id="{F7021451-1387-4CA6-816F-3879F97B5CBC}" type="slidenum">
               <a:rPr lang="en-US"/>
               <a:t>3</a:t>
-            </a:fld>
-            <a:endParaRPr lang="en-US"/>
-          </a:p>
-        </p:txBody>
-      </p:sp>
-    </p:spTree>
-    <p:extLst>
-      <p:ext uri="{BB962C8B-B14F-4D97-AF65-F5344CB8AC3E}">
-        <p14:creationId xmlns:p14="http://schemas.microsoft.com/office/powerpoint/2010/main" val="1024086991"/>
-      </p:ext>
-    </p:extLst>
-  </p:cSld>
-  <p:clrMapOvr>
-    <a:masterClrMapping/>
-  </p:clrMapOvr>
-</p:notes>
-</file>
-
-<file path=ppt/notesSlides/notesSlide4.xml><?xml version="1.0" encoding="utf-8"?>
-<p:notes xmlns:a="http://schemas.openxmlformats.org/drawingml/2006/main" xmlns:r="http://schemas.openxmlformats.org/officeDocument/2006/relationships" xmlns:p="http://schemas.openxmlformats.org/presentationml/2006/main">
-  <p:cSld>
-    <p:spTree>
-      <p:nvGrpSpPr>
-        <p:cNvPr id="1" name=""/>
-        <p:cNvGrpSpPr/>
-        <p:nvPr/>
-      </p:nvGrpSpPr>
-      <p:grpSpPr>
-        <a:xfrm>
-          <a:off x="0" y="0"/>
-          <a:ext cx="0" cy="0"/>
-          <a:chOff x="0" y="0"/>
-          <a:chExt cx="0" cy="0"/>
-        </a:xfrm>
-      </p:grpSpPr>
-      <p:sp>
-        <p:nvSpPr>
-          <p:cNvPr id="2" name="Slide Image Placeholder 1"/>
-          <p:cNvSpPr>
-            <a:spLocks noGrp="1" noRot="1" noChangeAspect="1"/>
-          </p:cNvSpPr>
-          <p:nvPr>
-            <p:ph type="sldImg"/>
-          </p:nvPr>
-        </p:nvSpPr>
-        <p:spPr/>
-      </p:sp>
-      <p:sp>
-        <p:nvSpPr>
-          <p:cNvPr id="3" name="Notes Placeholder 2"/>
-          <p:cNvSpPr>
-            <a:spLocks noGrp="1"/>
-          </p:cNvSpPr>
-          <p:nvPr>
-            <p:ph type="body" idx="1"/>
-          </p:nvPr>
-        </p:nvSpPr>
-        <p:spPr/>
-        <p:txBody>
-          <a:bodyPr/>
-          <a:lstStyle/>
-          <a:p>
-            <a:r>
-              <a:rPr lang="en-US" dirty="0"/>
-              <a:t>Land the plane on specifics. Ninety days, three phases, each one word — name it, see it, hold it — mapping directly back to the vision statement on slide 1. Nothing in the plan requires a purchase or new headcount, and the closing line says so explicitly because that is the first thing being calculated while this slide is on screen. The KPI panel is what makes this reportable next quarter, and none of the three is a savings number — allocation coverage says whether the data can be trusted, time-to-attribute says whether we can act, cost per unit says whether growth is healthy. Do not leave the room without the two decisions on the right. The second is the one people avoid — a limit that never blocks anything is treated as advisory, because it is. Ask directly whether we are willing to have a hard ceiling somewhere, and where. If asked about tooling: it is deliberately absent from this plan. A platform is worth evaluating once allocation cannot be fixed at source — that conversation comes after these ninety days, not instead of them.</a:t>
-            </a:r>
-            <a:endParaRPr lang="en-US" dirty="0"/>
-          </a:p>
-        </p:txBody>
-      </p:sp>
-      <p:sp>
-        <p:nvSpPr>
-          <p:cNvPr id="4" name="Slide Number Placeholder 3"/>
-          <p:cNvSpPr>
-            <a:spLocks noGrp="1"/>
-          </p:cNvSpPr>
-          <p:nvPr>
-            <p:ph type="sldNum" sz="quarter" idx="10"/>
-          </p:nvPr>
-        </p:nvSpPr>
-        <p:spPr/>
-        <p:txBody>
-          <a:bodyPr/>
-          <a:lstStyle/>
-          <a:p>
-            <a:fld id="{F7021451-1387-4CA6-816F-3879F97B5CBC}" type="slidenum">
-              <a:rPr lang="en-US"/>
-              <a:t>4</a:t>
             </a:fld>
             <a:endParaRPr lang="en-US"/>
           </a:p>
@@ -3891,1006 +3802,6 @@
               <a:t>“A cost alert cannot save you from a runaway job — by the time the billing data moves, the money is spent.”</a:t>
             </a:r>
             <a:endParaRPr lang="en-US" sz="1450" dirty="0"/>
-          </a:p>
-        </p:txBody>
-      </p:sp>
-    </p:spTree>
-  </p:cSld>
-  <p:clrMapOvr>
-    <a:masterClrMapping/>
-  </p:clrMapOvr>
-</p:sld>
-</file>
-
-<file path=ppt/slides/slide4.xml><?xml version="1.0" encoding="utf-8"?>
-<p:sld xmlns:a="http://schemas.openxmlformats.org/drawingml/2006/main" xmlns:r="http://schemas.openxmlformats.org/officeDocument/2006/relationships" xmlns:p="http://schemas.openxmlformats.org/presentationml/2006/main">
-  <p:cSld name="Slide 4">
-    <p:bg>
-      <p:bgPr>
-        <a:solidFill>
-          <a:srgbClr val="FFFFFF"/>
-        </a:solidFill>
-      </p:bgPr>
-    </p:bg>
-    <p:spTree>
-      <p:nvGrpSpPr>
-        <p:cNvPr id="1" name=""/>
-        <p:cNvGrpSpPr/>
-        <p:nvPr/>
-      </p:nvGrpSpPr>
-      <p:grpSpPr>
-        <a:xfrm>
-          <a:off x="0" y="0"/>
-          <a:ext cx="0" cy="0"/>
-          <a:chOff x="0" y="0"/>
-          <a:chExt cx="0" cy="0"/>
-        </a:xfrm>
-      </p:grpSpPr>
-      <p:sp>
-        <p:nvSpPr>
-          <p:cNvPr id="2" name="Text 0"/>
-          <p:cNvSpPr/>
-          <p:nvPr/>
-        </p:nvSpPr>
-        <p:spPr>
-          <a:xfrm>
-            <a:off x="548640" y="475488"/>
-            <a:ext cx="7315200" cy="256032"/>
-          </a:xfrm>
-          <a:prstGeom prst="rect">
-            <a:avLst/>
-          </a:prstGeom>
-          <a:noFill/>
-          <a:ln/>
-        </p:spPr>
-        <p:txBody>
-          <a:bodyPr wrap="square" lIns="0" tIns="0" rIns="0" bIns="0" rtlCol="0" anchor="ctr"/>
-          <a:lstStyle/>
-          <a:p>
-            <a:pPr indent="0" marL="0">
-              <a:buNone/>
-            </a:pPr>
-            <a:r>
-              <a:rPr lang="en-US" sz="1100" b="1" spc="220" kern="0" dirty="0">
-                <a:solidFill>
-                  <a:srgbClr val="E39B2C"/>
-                </a:solidFill>
-                <a:latin typeface="Calibri" pitchFamily="34" charset="0"/>
-                <a:ea typeface="Calibri" pitchFamily="34" charset="-122"/>
-                <a:cs typeface="Calibri" pitchFamily="34" charset="-120"/>
-              </a:rPr>
-              <a:t>WHAT WE ARE ASKING FOR</a:t>
-            </a:r>
-            <a:endParaRPr lang="en-US" sz="1100" dirty="0"/>
-          </a:p>
-        </p:txBody>
-      </p:sp>
-      <p:sp>
-        <p:nvSpPr>
-          <p:cNvPr id="3" name="Text 1"/>
-          <p:cNvSpPr/>
-          <p:nvPr/>
-        </p:nvSpPr>
-        <p:spPr>
-          <a:xfrm>
-            <a:off x="548640" y="768096"/>
-            <a:ext cx="11091672" cy="804672"/>
-          </a:xfrm>
-          <a:prstGeom prst="rect">
-            <a:avLst/>
-          </a:prstGeom>
-          <a:noFill/>
-          <a:ln/>
-        </p:spPr>
-        <p:txBody>
-          <a:bodyPr wrap="square" lIns="0" tIns="0" rIns="0" bIns="0" rtlCol="0" anchor="ctr"/>
-          <a:lstStyle/>
-          <a:p>
-            <a:pPr indent="0" marL="0">
-              <a:buNone/>
-            </a:pPr>
-            <a:r>
-              <a:rPr lang="en-US" sz="3100" b="1" dirty="0">
-                <a:solidFill>
-                  <a:srgbClr val="1B2430"/>
-                </a:solidFill>
-                <a:latin typeface="Cambria" pitchFamily="34" charset="0"/>
-                <a:ea typeface="Cambria" pitchFamily="34" charset="-122"/>
-                <a:cs typeface="Cambria" pitchFamily="34" charset="-120"/>
-              </a:rPr>
-              <a:t>Ninety days, and two decisions today</a:t>
-            </a:r>
-            <a:endParaRPr lang="en-US" sz="3100" dirty="0"/>
-          </a:p>
-        </p:txBody>
-      </p:sp>
-      <p:sp>
-        <p:nvSpPr>
-          <p:cNvPr id="4" name="Shape 2"/>
-          <p:cNvSpPr/>
-          <p:nvPr/>
-        </p:nvSpPr>
-        <p:spPr>
-          <a:xfrm>
-            <a:off x="548640" y="1965960"/>
-            <a:ext cx="3511296" cy="2148840"/>
-          </a:xfrm>
-          <a:prstGeom prst="roundRect">
-            <a:avLst>
-              <a:gd name="adj" fmla="val 3830"/>
-            </a:avLst>
-          </a:prstGeom>
-          <a:solidFill>
-            <a:srgbClr val="1F2936"/>
-          </a:solidFill>
-          <a:ln/>
-        </p:spPr>
-      </p:sp>
-      <p:sp>
-        <p:nvSpPr>
-          <p:cNvPr id="5" name="Text 3"/>
-          <p:cNvSpPr/>
-          <p:nvPr/>
-        </p:nvSpPr>
-        <p:spPr>
-          <a:xfrm>
-            <a:off x="859536" y="2139696"/>
-            <a:ext cx="2926080" cy="292608"/>
-          </a:xfrm>
-          <a:prstGeom prst="rect">
-            <a:avLst/>
-          </a:prstGeom>
-          <a:noFill/>
-          <a:ln/>
-        </p:spPr>
-        <p:txBody>
-          <a:bodyPr wrap="square" lIns="0" tIns="0" rIns="0" bIns="0" rtlCol="0" anchor="ctr"/>
-          <a:lstStyle/>
-          <a:p>
-            <a:pPr indent="0" marL="0">
-              <a:buNone/>
-            </a:pPr>
-            <a:r>
-              <a:rPr lang="en-US" sz="1150" b="1" spc="160" kern="0" dirty="0">
-                <a:solidFill>
-                  <a:srgbClr val="E39B2C"/>
-                </a:solidFill>
-                <a:latin typeface="Calibri" pitchFamily="34" charset="0"/>
-                <a:ea typeface="Calibri" pitchFamily="34" charset="-122"/>
-                <a:cs typeface="Calibri" pitchFamily="34" charset="-120"/>
-              </a:rPr>
-              <a:t>Weeks 1–4</a:t>
-            </a:r>
-            <a:endParaRPr lang="en-US" sz="1150" dirty="0"/>
-          </a:p>
-        </p:txBody>
-      </p:sp>
-      <p:sp>
-        <p:nvSpPr>
-          <p:cNvPr id="6" name="Text 4"/>
-          <p:cNvSpPr/>
-          <p:nvPr/>
-        </p:nvSpPr>
-        <p:spPr>
-          <a:xfrm>
-            <a:off x="859536" y="2468880"/>
-            <a:ext cx="2926080" cy="402336"/>
-          </a:xfrm>
-          <a:prstGeom prst="rect">
-            <a:avLst/>
-          </a:prstGeom>
-          <a:noFill/>
-          <a:ln/>
-        </p:spPr>
-        <p:txBody>
-          <a:bodyPr wrap="square" lIns="0" tIns="0" rIns="0" bIns="0" rtlCol="0" anchor="ctr"/>
-          <a:lstStyle/>
-          <a:p>
-            <a:pPr indent="0" marL="0">
-              <a:buNone/>
-            </a:pPr>
-            <a:r>
-              <a:rPr lang="en-US" sz="2000" b="1" dirty="0">
-                <a:solidFill>
-                  <a:srgbClr val="FFFFFF"/>
-                </a:solidFill>
-                <a:latin typeface="Cambria" pitchFamily="34" charset="0"/>
-                <a:ea typeface="Cambria" pitchFamily="34" charset="-122"/>
-                <a:cs typeface="Cambria" pitchFamily="34" charset="-120"/>
-              </a:rPr>
-              <a:t>Name it</a:t>
-            </a:r>
-            <a:endParaRPr lang="en-US" sz="2000" dirty="0"/>
-          </a:p>
-        </p:txBody>
-      </p:sp>
-      <p:sp>
-        <p:nvSpPr>
-          <p:cNvPr id="7" name="Text 5"/>
-          <p:cNvSpPr/>
-          <p:nvPr/>
-        </p:nvSpPr>
-        <p:spPr>
-          <a:xfrm>
-            <a:off x="859536" y="2962656"/>
-            <a:ext cx="2926080" cy="914400"/>
-          </a:xfrm>
-          <a:prstGeom prst="rect">
-            <a:avLst/>
-          </a:prstGeom>
-          <a:noFill/>
-          <a:ln/>
-        </p:spPr>
-        <p:txBody>
-          <a:bodyPr wrap="square" lIns="0" tIns="0" rIns="0" bIns="0" rtlCol="0" anchor="t"/>
-          <a:lstStyle/>
-          <a:p>
-            <a:pPr indent="0" marL="0">
-              <a:lnSpc>
-                <a:spcPts val="1700"/>
-              </a:lnSpc>
-              <a:buNone/>
-            </a:pPr>
-            <a:r>
-              <a:rPr lang="en-US" sz="1250" dirty="0">
-                <a:solidFill>
-                  <a:srgbClr val="9EABBA"/>
-                </a:solidFill>
-                <a:latin typeface="Calibri" pitchFamily="34" charset="0"/>
-                <a:ea typeface="Calibri" pitchFamily="34" charset="-122"/>
-                <a:cs typeface="Calibri" pitchFamily="34" charset="-120"/>
-              </a:rPr>
-              <a:t>Tag taxonomy published and enforced. An owner recorded for every application above a spend floor.</a:t>
-            </a:r>
-            <a:endParaRPr lang="en-US" sz="1250" dirty="0"/>
-          </a:p>
-        </p:txBody>
-      </p:sp>
-      <p:sp>
-        <p:nvSpPr>
-          <p:cNvPr id="8" name="Shape 6"/>
-          <p:cNvSpPr/>
-          <p:nvPr/>
-        </p:nvSpPr>
-        <p:spPr>
-          <a:xfrm>
-            <a:off x="4334256" y="1965960"/>
-            <a:ext cx="3511296" cy="2148840"/>
-          </a:xfrm>
-          <a:prstGeom prst="roundRect">
-            <a:avLst>
-              <a:gd name="adj" fmla="val 3830"/>
-            </a:avLst>
-          </a:prstGeom>
-          <a:solidFill>
-            <a:srgbClr val="F1F3F6"/>
-          </a:solidFill>
-          <a:ln/>
-        </p:spPr>
-      </p:sp>
-      <p:sp>
-        <p:nvSpPr>
-          <p:cNvPr id="9" name="Text 7"/>
-          <p:cNvSpPr/>
-          <p:nvPr/>
-        </p:nvSpPr>
-        <p:spPr>
-          <a:xfrm>
-            <a:off x="4645152" y="2139696"/>
-            <a:ext cx="2926080" cy="292608"/>
-          </a:xfrm>
-          <a:prstGeom prst="rect">
-            <a:avLst/>
-          </a:prstGeom>
-          <a:noFill/>
-          <a:ln/>
-        </p:spPr>
-        <p:txBody>
-          <a:bodyPr wrap="square" lIns="0" tIns="0" rIns="0" bIns="0" rtlCol="0" anchor="ctr"/>
-          <a:lstStyle/>
-          <a:p>
-            <a:pPr indent="0" marL="0">
-              <a:buNone/>
-            </a:pPr>
-            <a:r>
-              <a:rPr lang="en-US" sz="1150" b="1" spc="160" kern="0" dirty="0">
-                <a:solidFill>
-                  <a:srgbClr val="B87B18"/>
-                </a:solidFill>
-                <a:latin typeface="Calibri" pitchFamily="34" charset="0"/>
-                <a:ea typeface="Calibri" pitchFamily="34" charset="-122"/>
-                <a:cs typeface="Calibri" pitchFamily="34" charset="-120"/>
-              </a:rPr>
-              <a:t>Weeks 5–8</a:t>
-            </a:r>
-            <a:endParaRPr lang="en-US" sz="1150" dirty="0"/>
-          </a:p>
-        </p:txBody>
-      </p:sp>
-      <p:sp>
-        <p:nvSpPr>
-          <p:cNvPr id="10" name="Text 8"/>
-          <p:cNvSpPr/>
-          <p:nvPr/>
-        </p:nvSpPr>
-        <p:spPr>
-          <a:xfrm>
-            <a:off x="4645152" y="2468880"/>
-            <a:ext cx="2926080" cy="402336"/>
-          </a:xfrm>
-          <a:prstGeom prst="rect">
-            <a:avLst/>
-          </a:prstGeom>
-          <a:noFill/>
-          <a:ln/>
-        </p:spPr>
-        <p:txBody>
-          <a:bodyPr wrap="square" lIns="0" tIns="0" rIns="0" bIns="0" rtlCol="0" anchor="ctr"/>
-          <a:lstStyle/>
-          <a:p>
-            <a:pPr indent="0" marL="0">
-              <a:buNone/>
-            </a:pPr>
-            <a:r>
-              <a:rPr lang="en-US" sz="2000" b="1" dirty="0">
-                <a:solidFill>
-                  <a:srgbClr val="1B2430"/>
-                </a:solidFill>
-                <a:latin typeface="Cambria" pitchFamily="34" charset="0"/>
-                <a:ea typeface="Cambria" pitchFamily="34" charset="-122"/>
-                <a:cs typeface="Cambria" pitchFamily="34" charset="-120"/>
-              </a:rPr>
-              <a:t>See it</a:t>
-            </a:r>
-            <a:endParaRPr lang="en-US" sz="2000" dirty="0"/>
-          </a:p>
-        </p:txBody>
-      </p:sp>
-      <p:sp>
-        <p:nvSpPr>
-          <p:cNvPr id="11" name="Text 9"/>
-          <p:cNvSpPr/>
-          <p:nvPr/>
-        </p:nvSpPr>
-        <p:spPr>
-          <a:xfrm>
-            <a:off x="4645152" y="2962656"/>
-            <a:ext cx="2926080" cy="914400"/>
-          </a:xfrm>
-          <a:prstGeom prst="rect">
-            <a:avLst/>
-          </a:prstGeom>
-          <a:noFill/>
-          <a:ln/>
-        </p:spPr>
-        <p:txBody>
-          <a:bodyPr wrap="square" lIns="0" tIns="0" rIns="0" bIns="0" rtlCol="0" anchor="t"/>
-          <a:lstStyle/>
-          <a:p>
-            <a:pPr indent="0" marL="0">
-              <a:lnSpc>
-                <a:spcPts val="1700"/>
-              </a:lnSpc>
-              <a:buNone/>
-            </a:pPr>
-            <a:r>
-              <a:rPr lang="en-US" sz="1250" dirty="0">
-                <a:solidFill>
-                  <a:srgbClr val="5C6675"/>
-                </a:solidFill>
-                <a:latin typeface="Calibri" pitchFamily="34" charset="0"/>
-                <a:ea typeface="Calibri" pitchFamily="34" charset="-122"/>
-                <a:cs typeface="Calibri" pitchFamily="34" charset="-120"/>
-              </a:rPr>
-              <a:t>One number per project, showback to every team, and cost in the design review.</a:t>
-            </a:r>
-            <a:endParaRPr lang="en-US" sz="1250" dirty="0"/>
-          </a:p>
-        </p:txBody>
-      </p:sp>
-      <p:sp>
-        <p:nvSpPr>
-          <p:cNvPr id="12" name="Shape 10"/>
-          <p:cNvSpPr/>
-          <p:nvPr/>
-        </p:nvSpPr>
-        <p:spPr>
-          <a:xfrm>
-            <a:off x="8119872" y="1965960"/>
-            <a:ext cx="3511296" cy="2148840"/>
-          </a:xfrm>
-          <a:prstGeom prst="roundRect">
-            <a:avLst>
-              <a:gd name="adj" fmla="val 3830"/>
-            </a:avLst>
-          </a:prstGeom>
-          <a:solidFill>
-            <a:srgbClr val="F1F3F6"/>
-          </a:solidFill>
-          <a:ln/>
-        </p:spPr>
-      </p:sp>
-      <p:sp>
-        <p:nvSpPr>
-          <p:cNvPr id="13" name="Text 11"/>
-          <p:cNvSpPr/>
-          <p:nvPr/>
-        </p:nvSpPr>
-        <p:spPr>
-          <a:xfrm>
-            <a:off x="8430768" y="2139696"/>
-            <a:ext cx="2926080" cy="292608"/>
-          </a:xfrm>
-          <a:prstGeom prst="rect">
-            <a:avLst/>
-          </a:prstGeom>
-          <a:noFill/>
-          <a:ln/>
-        </p:spPr>
-        <p:txBody>
-          <a:bodyPr wrap="square" lIns="0" tIns="0" rIns="0" bIns="0" rtlCol="0" anchor="ctr"/>
-          <a:lstStyle/>
-          <a:p>
-            <a:pPr indent="0" marL="0">
-              <a:buNone/>
-            </a:pPr>
-            <a:r>
-              <a:rPr lang="en-US" sz="1150" b="1" spc="160" kern="0" dirty="0">
-                <a:solidFill>
-                  <a:srgbClr val="B87B18"/>
-                </a:solidFill>
-                <a:latin typeface="Calibri" pitchFamily="34" charset="0"/>
-                <a:ea typeface="Calibri" pitchFamily="34" charset="-122"/>
-                <a:cs typeface="Calibri" pitchFamily="34" charset="-120"/>
-              </a:rPr>
-              <a:t>Weeks 9–12</a:t>
-            </a:r>
-            <a:endParaRPr lang="en-US" sz="1150" dirty="0"/>
-          </a:p>
-        </p:txBody>
-      </p:sp>
-      <p:sp>
-        <p:nvSpPr>
-          <p:cNvPr id="14" name="Text 12"/>
-          <p:cNvSpPr/>
-          <p:nvPr/>
-        </p:nvSpPr>
-        <p:spPr>
-          <a:xfrm>
-            <a:off x="8430768" y="2468880"/>
-            <a:ext cx="2926080" cy="402336"/>
-          </a:xfrm>
-          <a:prstGeom prst="rect">
-            <a:avLst/>
-          </a:prstGeom>
-          <a:noFill/>
-          <a:ln/>
-        </p:spPr>
-        <p:txBody>
-          <a:bodyPr wrap="square" lIns="0" tIns="0" rIns="0" bIns="0" rtlCol="0" anchor="ctr"/>
-          <a:lstStyle/>
-          <a:p>
-            <a:pPr indent="0" marL="0">
-              <a:buNone/>
-            </a:pPr>
-            <a:r>
-              <a:rPr lang="en-US" sz="2000" b="1" dirty="0">
-                <a:solidFill>
-                  <a:srgbClr val="1B2430"/>
-                </a:solidFill>
-                <a:latin typeface="Cambria" pitchFamily="34" charset="0"/>
-                <a:ea typeface="Cambria" pitchFamily="34" charset="-122"/>
-                <a:cs typeface="Cambria" pitchFamily="34" charset="-120"/>
-              </a:rPr>
-              <a:t>Hold it</a:t>
-            </a:r>
-            <a:endParaRPr lang="en-US" sz="2000" dirty="0"/>
-          </a:p>
-        </p:txBody>
-      </p:sp>
-      <p:sp>
-        <p:nvSpPr>
-          <p:cNvPr id="15" name="Text 13"/>
-          <p:cNvSpPr/>
-          <p:nvPr/>
-        </p:nvSpPr>
-        <p:spPr>
-          <a:xfrm>
-            <a:off x="8430768" y="2962656"/>
-            <a:ext cx="2926080" cy="914400"/>
-          </a:xfrm>
-          <a:prstGeom prst="rect">
-            <a:avLst/>
-          </a:prstGeom>
-          <a:noFill/>
-          <a:ln/>
-        </p:spPr>
-        <p:txBody>
-          <a:bodyPr wrap="square" lIns="0" tIns="0" rIns="0" bIns="0" rtlCol="0" anchor="t"/>
-          <a:lstStyle/>
-          <a:p>
-            <a:pPr indent="0" marL="0">
-              <a:lnSpc>
-                <a:spcPts val="1700"/>
-              </a:lnSpc>
-              <a:buNone/>
-            </a:pPr>
-            <a:r>
-              <a:rPr lang="en-US" sz="1250" dirty="0">
-                <a:solidFill>
-                  <a:srgbClr val="5C6675"/>
-                </a:solidFill>
-                <a:latin typeface="Calibri" pitchFamily="34" charset="0"/>
-                <a:ea typeface="Calibri" pitchFamily="34" charset="-122"/>
-                <a:cs typeface="Calibri" pitchFamily="34" charset="-120"/>
-              </a:rPr>
-              <a:t>Quotas on the largest workloads, alerts routed to owners, monthly review with finance.</a:t>
-            </a:r>
-            <a:endParaRPr lang="en-US" sz="1250" dirty="0"/>
-          </a:p>
-        </p:txBody>
-      </p:sp>
-      <p:sp>
-        <p:nvSpPr>
-          <p:cNvPr id="16" name="Shape 14"/>
-          <p:cNvSpPr/>
-          <p:nvPr/>
-        </p:nvSpPr>
-        <p:spPr>
-          <a:xfrm>
-            <a:off x="548640" y="4352544"/>
-            <a:ext cx="5394960" cy="1463040"/>
-          </a:xfrm>
-          <a:prstGeom prst="roundRect">
-            <a:avLst>
-              <a:gd name="adj" fmla="val 5625"/>
-            </a:avLst>
-          </a:prstGeom>
-          <a:solidFill>
-            <a:srgbClr val="F1F3F6"/>
-          </a:solidFill>
-          <a:ln/>
-        </p:spPr>
-      </p:sp>
-      <p:sp>
-        <p:nvSpPr>
-          <p:cNvPr id="17" name="Text 15"/>
-          <p:cNvSpPr/>
-          <p:nvPr/>
-        </p:nvSpPr>
-        <p:spPr>
-          <a:xfrm>
-            <a:off x="859536" y="4517136"/>
-            <a:ext cx="4572000" cy="274320"/>
-          </a:xfrm>
-          <a:prstGeom prst="rect">
-            <a:avLst/>
-          </a:prstGeom>
-          <a:noFill/>
-          <a:ln/>
-        </p:spPr>
-        <p:txBody>
-          <a:bodyPr wrap="square" lIns="0" tIns="0" rIns="0" bIns="0" rtlCol="0" anchor="ctr"/>
-          <a:lstStyle/>
-          <a:p>
-            <a:pPr indent="0" marL="0">
-              <a:buNone/>
-            </a:pPr>
-            <a:r>
-              <a:rPr lang="en-US" sz="1150" b="1" spc="140" kern="0" dirty="0">
-                <a:solidFill>
-                  <a:srgbClr val="5C6675"/>
-                </a:solidFill>
-                <a:latin typeface="Calibri" pitchFamily="34" charset="0"/>
-                <a:ea typeface="Calibri" pitchFamily="34" charset="-122"/>
-                <a:cs typeface="Calibri" pitchFamily="34" charset="-120"/>
-              </a:rPr>
-              <a:t>How we will know it is working</a:t>
-            </a:r>
-            <a:endParaRPr lang="en-US" sz="1150" dirty="0"/>
-          </a:p>
-        </p:txBody>
-      </p:sp>
-      <p:sp>
-        <p:nvSpPr>
-          <p:cNvPr id="18" name="Text 16"/>
-          <p:cNvSpPr/>
-          <p:nvPr/>
-        </p:nvSpPr>
-        <p:spPr>
-          <a:xfrm>
-            <a:off x="859536" y="4846320"/>
-            <a:ext cx="2743200" cy="274320"/>
-          </a:xfrm>
-          <a:prstGeom prst="rect">
-            <a:avLst/>
-          </a:prstGeom>
-          <a:noFill/>
-          <a:ln/>
-        </p:spPr>
-        <p:txBody>
-          <a:bodyPr wrap="square" lIns="0" tIns="0" rIns="0" bIns="0" rtlCol="0" anchor="ctr"/>
-          <a:lstStyle/>
-          <a:p>
-            <a:pPr indent="0" marL="0">
-              <a:buNone/>
-            </a:pPr>
-            <a:r>
-              <a:rPr lang="en-US" sz="1250" b="1" dirty="0">
-                <a:solidFill>
-                  <a:srgbClr val="1B2430"/>
-                </a:solidFill>
-                <a:latin typeface="Calibri" pitchFamily="34" charset="0"/>
-                <a:ea typeface="Calibri" pitchFamily="34" charset="-122"/>
-                <a:cs typeface="Calibri" pitchFamily="34" charset="-120"/>
-              </a:rPr>
-              <a:t>Allocation coverage</a:t>
-            </a:r>
-            <a:endParaRPr lang="en-US" sz="1250" dirty="0"/>
-          </a:p>
-        </p:txBody>
-      </p:sp>
-      <p:sp>
-        <p:nvSpPr>
-          <p:cNvPr id="19" name="Text 17"/>
-          <p:cNvSpPr/>
-          <p:nvPr/>
-        </p:nvSpPr>
-        <p:spPr>
-          <a:xfrm>
-            <a:off x="3657600" y="4846320"/>
-            <a:ext cx="1975104" cy="274320"/>
-          </a:xfrm>
-          <a:prstGeom prst="rect">
-            <a:avLst/>
-          </a:prstGeom>
-          <a:noFill/>
-          <a:ln/>
-        </p:spPr>
-        <p:txBody>
-          <a:bodyPr wrap="square" lIns="0" tIns="0" rIns="0" bIns="0" rtlCol="0" anchor="ctr"/>
-          <a:lstStyle/>
-          <a:p>
-            <a:pPr algn="r" indent="0" marL="0">
-              <a:buNone/>
-            </a:pPr>
-            <a:r>
-              <a:rPr lang="en-US" sz="1250" dirty="0">
-                <a:solidFill>
-                  <a:srgbClr val="5C6675"/>
-                </a:solidFill>
-                <a:latin typeface="Calibri" pitchFamily="34" charset="0"/>
-                <a:ea typeface="Calibri" pitchFamily="34" charset="-122"/>
-                <a:cs typeface="Calibri" pitchFamily="34" charset="-120"/>
-              </a:rPr>
-              <a:t>under 5%</a:t>
-            </a:r>
-            <a:endParaRPr lang="en-US" sz="1250" dirty="0"/>
-          </a:p>
-        </p:txBody>
-      </p:sp>
-      <p:sp>
-        <p:nvSpPr>
-          <p:cNvPr id="20" name="Text 18"/>
-          <p:cNvSpPr/>
-          <p:nvPr/>
-        </p:nvSpPr>
-        <p:spPr>
-          <a:xfrm>
-            <a:off x="859536" y="5148072"/>
-            <a:ext cx="2743200" cy="274320"/>
-          </a:xfrm>
-          <a:prstGeom prst="rect">
-            <a:avLst/>
-          </a:prstGeom>
-          <a:noFill/>
-          <a:ln/>
-        </p:spPr>
-        <p:txBody>
-          <a:bodyPr wrap="square" lIns="0" tIns="0" rIns="0" bIns="0" rtlCol="0" anchor="ctr"/>
-          <a:lstStyle/>
-          <a:p>
-            <a:pPr indent="0" marL="0">
-              <a:buNone/>
-            </a:pPr>
-            <a:r>
-              <a:rPr lang="en-US" sz="1250" b="1" dirty="0">
-                <a:solidFill>
-                  <a:srgbClr val="1B2430"/>
-                </a:solidFill>
-                <a:latin typeface="Calibri" pitchFamily="34" charset="0"/>
-                <a:ea typeface="Calibri" pitchFamily="34" charset="-122"/>
-                <a:cs typeface="Calibri" pitchFamily="34" charset="-120"/>
-              </a:rPr>
-              <a:t>Time to attribute a spike</a:t>
-            </a:r>
-            <a:endParaRPr lang="en-US" sz="1250" dirty="0"/>
-          </a:p>
-        </p:txBody>
-      </p:sp>
-      <p:sp>
-        <p:nvSpPr>
-          <p:cNvPr id="21" name="Text 19"/>
-          <p:cNvSpPr/>
-          <p:nvPr/>
-        </p:nvSpPr>
-        <p:spPr>
-          <a:xfrm>
-            <a:off x="3657600" y="5148072"/>
-            <a:ext cx="1975104" cy="274320"/>
-          </a:xfrm>
-          <a:prstGeom prst="rect">
-            <a:avLst/>
-          </a:prstGeom>
-          <a:noFill/>
-          <a:ln/>
-        </p:spPr>
-        <p:txBody>
-          <a:bodyPr wrap="square" lIns="0" tIns="0" rIns="0" bIns="0" rtlCol="0" anchor="ctr"/>
-          <a:lstStyle/>
-          <a:p>
-            <a:pPr algn="r" indent="0" marL="0">
-              <a:buNone/>
-            </a:pPr>
-            <a:r>
-              <a:rPr lang="en-US" sz="1250" dirty="0">
-                <a:solidFill>
-                  <a:srgbClr val="5C6675"/>
-                </a:solidFill>
-                <a:latin typeface="Calibri" pitchFamily="34" charset="0"/>
-                <a:ea typeface="Calibri" pitchFamily="34" charset="-122"/>
-                <a:cs typeface="Calibri" pitchFamily="34" charset="-120"/>
-              </a:rPr>
-              <a:t>hours, not days</a:t>
-            </a:r>
-            <a:endParaRPr lang="en-US" sz="1250" dirty="0"/>
-          </a:p>
-        </p:txBody>
-      </p:sp>
-      <p:sp>
-        <p:nvSpPr>
-          <p:cNvPr id="22" name="Text 20"/>
-          <p:cNvSpPr/>
-          <p:nvPr/>
-        </p:nvSpPr>
-        <p:spPr>
-          <a:xfrm>
-            <a:off x="859536" y="5449824"/>
-            <a:ext cx="2743200" cy="274320"/>
-          </a:xfrm>
-          <a:prstGeom prst="rect">
-            <a:avLst/>
-          </a:prstGeom>
-          <a:noFill/>
-          <a:ln/>
-        </p:spPr>
-        <p:txBody>
-          <a:bodyPr wrap="square" lIns="0" tIns="0" rIns="0" bIns="0" rtlCol="0" anchor="ctr"/>
-          <a:lstStyle/>
-          <a:p>
-            <a:pPr indent="0" marL="0">
-              <a:buNone/>
-            </a:pPr>
-            <a:r>
-              <a:rPr lang="en-US" sz="1250" b="1" dirty="0">
-                <a:solidFill>
-                  <a:srgbClr val="1B2430"/>
-                </a:solidFill>
-                <a:latin typeface="Calibri" pitchFamily="34" charset="0"/>
-                <a:ea typeface="Calibri" pitchFamily="34" charset="-122"/>
-                <a:cs typeface="Calibri" pitchFamily="34" charset="-120"/>
-              </a:rPr>
-              <a:t>Cost per unit</a:t>
-            </a:r>
-            <a:endParaRPr lang="en-US" sz="1250" dirty="0"/>
-          </a:p>
-        </p:txBody>
-      </p:sp>
-      <p:sp>
-        <p:nvSpPr>
-          <p:cNvPr id="23" name="Text 21"/>
-          <p:cNvSpPr/>
-          <p:nvPr/>
-        </p:nvSpPr>
-        <p:spPr>
-          <a:xfrm>
-            <a:off x="3657600" y="5449824"/>
-            <a:ext cx="1975104" cy="274320"/>
-          </a:xfrm>
-          <a:prstGeom prst="rect">
-            <a:avLst/>
-          </a:prstGeom>
-          <a:noFill/>
-          <a:ln/>
-        </p:spPr>
-        <p:txBody>
-          <a:bodyPr wrap="square" lIns="0" tIns="0" rIns="0" bIns="0" rtlCol="0" anchor="ctr"/>
-          <a:lstStyle/>
-          <a:p>
-            <a:pPr algn="r" indent="0" marL="0">
-              <a:buNone/>
-            </a:pPr>
-            <a:r>
-              <a:rPr lang="en-US" sz="1250" dirty="0">
-                <a:solidFill>
-                  <a:srgbClr val="5C6675"/>
-                </a:solidFill>
-                <a:latin typeface="Calibri" pitchFamily="34" charset="0"/>
-                <a:ea typeface="Calibri" pitchFamily="34" charset="-122"/>
-                <a:cs typeface="Calibri" pitchFamily="34" charset="-120"/>
-              </a:rPr>
-              <a:t>trending, per project</a:t>
-            </a:r>
-            <a:endParaRPr lang="en-US" sz="1250" dirty="0"/>
-          </a:p>
-        </p:txBody>
-      </p:sp>
-      <p:sp>
-        <p:nvSpPr>
-          <p:cNvPr id="24" name="Shape 22"/>
-          <p:cNvSpPr/>
-          <p:nvPr/>
-        </p:nvSpPr>
-        <p:spPr>
-          <a:xfrm>
-            <a:off x="6245352" y="4352544"/>
-            <a:ext cx="5394960" cy="1536192"/>
-          </a:xfrm>
-          <a:prstGeom prst="roundRect">
-            <a:avLst>
-              <a:gd name="adj" fmla="val 5357"/>
-            </a:avLst>
-          </a:prstGeom>
-          <a:solidFill>
-            <a:srgbClr val="1F2936"/>
-          </a:solidFill>
-          <a:ln/>
-          <a:effectLst>
-            <a:outerShdw sx="100000" sy="100000" kx="0" ky="0" algn="bl" rotWithShape="0" blurRad="127000" dist="25400" dir="5400000">
-              <a:srgbClr val="8C99A8">
-                <a:alpha val="16000"/>
-              </a:srgbClr>
-            </a:outerShdw>
-          </a:effectLst>
-        </p:spPr>
-      </p:sp>
-      <p:sp>
-        <p:nvSpPr>
-          <p:cNvPr id="25" name="Text 23"/>
-          <p:cNvSpPr/>
-          <p:nvPr/>
-        </p:nvSpPr>
-        <p:spPr>
-          <a:xfrm>
-            <a:off x="6556248" y="4517136"/>
-            <a:ext cx="4572000" cy="274320"/>
-          </a:xfrm>
-          <a:prstGeom prst="rect">
-            <a:avLst/>
-          </a:prstGeom>
-          <a:noFill/>
-          <a:ln/>
-        </p:spPr>
-        <p:txBody>
-          <a:bodyPr wrap="square" lIns="0" tIns="0" rIns="0" bIns="0" rtlCol="0" anchor="ctr"/>
-          <a:lstStyle/>
-          <a:p>
-            <a:pPr indent="0" marL="0">
-              <a:buNone/>
-            </a:pPr>
-            <a:r>
-              <a:rPr lang="en-US" sz="1150" b="1" spc="140" kern="0" dirty="0">
-                <a:solidFill>
-                  <a:srgbClr val="E39B2C"/>
-                </a:solidFill>
-                <a:latin typeface="Calibri" pitchFamily="34" charset="0"/>
-                <a:ea typeface="Calibri" pitchFamily="34" charset="-122"/>
-                <a:cs typeface="Calibri" pitchFamily="34" charset="-120"/>
-              </a:rPr>
-              <a:t>Decisions needed today</a:t>
-            </a:r>
-            <a:endParaRPr lang="en-US" sz="1150" dirty="0"/>
-          </a:p>
-        </p:txBody>
-      </p:sp>
-      <p:sp>
-        <p:nvSpPr>
-          <p:cNvPr id="26" name="Text 24"/>
-          <p:cNvSpPr/>
-          <p:nvPr/>
-        </p:nvSpPr>
-        <p:spPr>
-          <a:xfrm>
-            <a:off x="6556248" y="4828032"/>
-            <a:ext cx="4846320" cy="960120"/>
-          </a:xfrm>
-          <a:prstGeom prst="rect">
-            <a:avLst/>
-          </a:prstGeom>
-          <a:noFill/>
-          <a:ln/>
-        </p:spPr>
-        <p:txBody>
-          <a:bodyPr wrap="square" lIns="0" tIns="0" rIns="0" bIns="0" rtlCol="0" anchor="t"/>
-          <a:lstStyle/>
-          <a:p>
-            <a:pPr indent="0" marL="0">
-              <a:lnSpc>
-                <a:spcPts val="2200"/>
-              </a:lnSpc>
-              <a:buNone/>
-            </a:pPr>
-            <a:r>
-              <a:rPr lang="en-US" sz="1350" b="1" dirty="0">
-                <a:solidFill>
-                  <a:srgbClr val="FFFFFF"/>
-                </a:solidFill>
-                <a:latin typeface="Calibri" pitchFamily="34" charset="0"/>
-                <a:ea typeface="Calibri" pitchFamily="34" charset="-122"/>
-                <a:cs typeface="Calibri" pitchFamily="34" charset="-120"/>
-              </a:rPr>
-              <a:t>1.  Who owns the tagging standard, and by when?</a:t>
-            </a:r>
-            <a:endParaRPr lang="en-US" sz="1350" dirty="0"/>
-          </a:p>
-          <a:p>
-            <a:pPr indent="0" marL="0">
-              <a:lnSpc>
-                <a:spcPts val="2200"/>
-              </a:lnSpc>
-              <a:buNone/>
-            </a:pPr>
-            <a:r>
-              <a:rPr lang="en-US" sz="1350" b="1" dirty="0">
-                <a:solidFill>
-                  <a:srgbClr val="FFFFFF"/>
-                </a:solidFill>
-                <a:latin typeface="Calibri" pitchFamily="34" charset="0"/>
-                <a:ea typeface="Calibri" pitchFamily="34" charset="-122"/>
-                <a:cs typeface="Calibri" pitchFamily="34" charset="-120"/>
-              </a:rPr>
-              <a:t>2.  Are we willing to have a limit that blocks?</a:t>
-            </a:r>
-            <a:endParaRPr lang="en-US" sz="1350" dirty="0"/>
-          </a:p>
-        </p:txBody>
-      </p:sp>
-      <p:sp>
-        <p:nvSpPr>
-          <p:cNvPr id="27" name="Text 25"/>
-          <p:cNvSpPr/>
-          <p:nvPr/>
-        </p:nvSpPr>
-        <p:spPr>
-          <a:xfrm>
-            <a:off x="548640" y="5998464"/>
-            <a:ext cx="11091672" cy="457200"/>
-          </a:xfrm>
-          <a:prstGeom prst="rect">
-            <a:avLst/>
-          </a:prstGeom>
-          <a:noFill/>
-          <a:ln/>
-        </p:spPr>
-        <p:txBody>
-          <a:bodyPr wrap="square" lIns="0" tIns="0" rIns="0" bIns="0" rtlCol="0" anchor="ctr"/>
-          <a:lstStyle/>
-          <a:p>
-            <a:pPr indent="0" marL="0">
-              <a:buNone/>
-            </a:pPr>
-            <a:r>
-              <a:rPr lang="en-US" sz="1250" dirty="0">
-                <a:solidFill>
-                  <a:srgbClr val="5C6675"/>
-                </a:solidFill>
-                <a:latin typeface="Calibri" pitchFamily="34" charset="0"/>
-                <a:ea typeface="Calibri" pitchFamily="34" charset="-122"/>
-                <a:cs typeface="Calibri" pitchFamily="34" charset="-120"/>
-              </a:rPr>
-              <a:t>No new headcount and no platform purchase in this plan. A tooling decision comes later, and only if allocation cannot be fixed at source.</a:t>
-            </a:r>
-            <a:endParaRPr lang="en-US" sz="1250" dirty="0"/>
           </a:p>
         </p:txBody>
       </p:sp>

</xml_diff>